<commit_message>
fix(presentacion): asignación manual correcta para 2026-09-27
- Aplica la selección de canciones indicada por el usuario para el XXVI Domingo T.O.
- Entrada, Gloria, Aleluya, Ofertorio, Santo, Paz, Comunión, Canto a María,
  Despedida con canciones concretas.
- Perdón, Salmo y Padre Nuestro se dejan como textos litúrgicos.
- Regenera PPTX fieles, hoja de músicos (PDF) y bundle web.
</commit_message>
<xml_diff>
--- a/presentaciones/2026-09-27_celebracion.pptx
+++ b/presentaciones/2026-09-27_celebracion.pptx
@@ -23,7 +23,6 @@
     <p:sldId id="271" r:id="rId22"/>
     <p:sldId id="272" r:id="rId23"/>
     <p:sldId id="273" r:id="rId24"/>
-    <p:sldId id="274" r:id="rId25"/>
   </p:sldIdLst>
   <p:sldSz cx="12193200" cy="9144900" type="screen4x3"/>
   <p:notesSz cx="6858000" cy="9144000"/>
@@ -3446,7 +3445,7 @@
       </p:pic>
       <p:pic>
         <p:nvPicPr>
-          <p:cNvPr id="4" name="Picture 3" descr="fano_20140639_sin_titulo.jpg"/>
+          <p:cNvPr id="4" name="Picture 3" descr="fano_20140794_una_semillita_de_fe_es_un_sueño_de_amor_para_mí_siémbrala.jpg"/>
           <p:cNvPicPr>
             <a:picLocks noChangeAspect="1"/>
           </p:cNvPicPr>
@@ -3461,7 +3460,7 @@
         <p:spPr>
           <a:xfrm>
             <a:off x="6675120" y="1005840"/>
-            <a:ext cx="4000500" cy="2560320"/>
+            <a:ext cx="2984553" cy="2560320"/>
           </a:xfrm>
           <a:prstGeom prst="rect">
             <a:avLst/>
@@ -3584,7 +3583,7 @@
                   <a:srgbClr val="7C3AED"/>
                 </a:solidFill>
               </a:rPr>
-              <a:t>EVANGELIO</a:t>
+              <a:t>CREDO</a:t>
             </a:r>
           </a:p>
           <a:p>
@@ -3598,26 +3597,6 @@
             </a:pPr>
           </a:p>
           <a:p>
-            <a:r>
-              <a:rPr b="1" sz="1500">
-                <a:solidFill>
-                  <a:srgbClr val="D4A76A"/>
-                </a:solidFill>
-              </a:rPr>
-              <a:t>Mateo 21,28-32</a:t>
-            </a:r>
-          </a:p>
-          <a:p>
-            <a:pPr>
-              <a:spcBef>
-                <a:spcPts val="0"/>
-              </a:spcBef>
-              <a:spcAft>
-                <a:spcPts val="0"/>
-              </a:spcAft>
-            </a:pPr>
-          </a:p>
-          <a:p>
             <a:pPr>
               <a:lnSpc>
                 <a:spcPct val="115000"/>
@@ -3629,7 +3608,7 @@
                   <a:srgbClr val="37352F"/>
                 </a:solidFill>
               </a:rPr>
-              <a:t>En aquel tiempo, dijo Jesús a los sumos sacerdotes y a los ancianos del pueblo: «¿Qué os parece? Un hombre tenía dos hijos. Se acercó al primero y le dijo: «Hijo, ve hoy a trabajar en la viña.» Él le contestó: «No quiero.» Pero después recapacitó y fue. Se acercó al segundo y le dijo lo mismo. Él le contestó: «Voy, señor.» Pero no fue. ¿Quién de los dos hizo lo que quería el padre?»Contestaron: «El primero.»Jesús les dijo: «Os aseguro que los publicanos y las prostitutas os llevan la delantera en el camino del reino de Dios. Porque vino Juan a vosotros enseñándoos el camino de la justicia, y no le creísteis; en cambio, los publicanos y prostitutas le creyeron. Y, aun después de ver esto, vosotros no recapacitasteis ni le creísteis.»</a:t>
+              <a:t>Creo en Dios, Padre todopoderoso, creador del cielo y de la tierra.</a:t>
             </a:r>
           </a:p>
           <a:p>
@@ -3644,7 +3623,37 @@
                   <a:srgbClr val="37352F"/>
                 </a:solidFill>
               </a:rPr>
-              <a:t>Palabra del Señor</a:t>
+              <a:t>Creo en Jesucristo, su único Hijo, nuestro Señor, que fue concebido por obra y gracia del Espíritu Santo; nació de Santa María Virgen; padeció bajo el poder de Poncio Pilato; fue crucificado, muerto y sepultado; descendió a los infiernos; al tercer día resucitó de entre los muertos; subió a los cielos y está sentado a la derecha de Dios Padre todopoderoso.</a:t>
+            </a:r>
+          </a:p>
+          <a:p>
+            <a:pPr>
+              <a:lnSpc>
+                <a:spcPct val="115000"/>
+              </a:lnSpc>
+            </a:pPr>
+            <a:r>
+              <a:rPr b="0" sz="2000">
+                <a:solidFill>
+                  <a:srgbClr val="37352F"/>
+                </a:solidFill>
+              </a:rPr>
+              <a:t>Desde allí ha de venir a juzgar a vivos y muertos.</a:t>
+            </a:r>
+          </a:p>
+          <a:p>
+            <a:pPr>
+              <a:lnSpc>
+                <a:spcPct val="115000"/>
+              </a:lnSpc>
+            </a:pPr>
+            <a:r>
+              <a:rPr b="0" sz="2000">
+                <a:solidFill>
+                  <a:srgbClr val="37352F"/>
+                </a:solidFill>
+              </a:rPr>
+              <a:t>Creo en el Espíritu Santo, la santa Iglesia católica, la comunión de los santos, el perdón de los pecados, la resurrección de la carne y la vida eterna. Amén.</a:t>
             </a:r>
           </a:p>
         </p:txBody>
@@ -3744,7 +3753,7 @@
       </p:pic>
       <p:pic>
         <p:nvPicPr>
-          <p:cNvPr id="4" name="Picture 3" descr="fano_20140794_una_semillita_de_fe_es_un_sueño_de_amor_para_mí_siémbrala.jpg"/>
+          <p:cNvPr id="4" name="Picture 3" descr="fano_20140880_dadles_vosotros_de_comer.jpg"/>
           <p:cNvPicPr>
             <a:picLocks noChangeAspect="1"/>
           </p:cNvPicPr>
@@ -3759,7 +3768,7 @@
         <p:spPr>
           <a:xfrm>
             <a:off x="6675120" y="1005840"/>
-            <a:ext cx="2984553" cy="2560320"/>
+            <a:ext cx="3213791" cy="2560320"/>
           </a:xfrm>
           <a:prstGeom prst="rect">
             <a:avLst/>
@@ -3877,12 +3886,22 @@
           <a:lstStyle/>
           <a:p>
             <a:r>
+              <a:rPr b="1" sz="1500">
+                <a:solidFill>
+                  <a:srgbClr val="7C3AED"/>
+                </a:solidFill>
+              </a:rPr>
+              <a:t>OFERTORIO</a:t>
+            </a:r>
+          </a:p>
+          <a:p>
+            <a:r>
               <a:rPr b="1" sz="2600">
                 <a:solidFill>
                   <a:srgbClr val="7C3AED"/>
                 </a:solidFill>
               </a:rPr>
-              <a:t>CREDO</a:t>
+              <a:t>QUE TE PUEDO DAR</a:t>
             </a:r>
           </a:p>
           <a:p>
@@ -3898,61 +3917,91 @@
           <a:p>
             <a:pPr>
               <a:lnSpc>
-                <a:spcPct val="115000"/>
-              </a:lnSpc>
-            </a:pPr>
-            <a:r>
-              <a:rPr b="0" sz="2000">
-                <a:solidFill>
-                  <a:srgbClr val="37352F"/>
-                </a:solidFill>
-              </a:rPr>
-              <a:t>Creo en Dios, Padre todopoderoso, creador del cielo y de la tierra.</a:t>
-            </a:r>
-          </a:p>
-          <a:p>
-            <a:pPr>
-              <a:lnSpc>
-                <a:spcPct val="115000"/>
-              </a:lnSpc>
-            </a:pPr>
-            <a:r>
-              <a:rPr b="0" sz="2000">
-                <a:solidFill>
-                  <a:srgbClr val="37352F"/>
-                </a:solidFill>
-              </a:rPr>
-              <a:t>Creo en Jesucristo, su único Hijo, nuestro Señor, que fue concebido por obra y gracia del Espíritu Santo; nació de Santa María Virgen; padeció bajo el poder de Poncio Pilato; fue crucificado, muerto y sepultado; descendió a los infiernos; al tercer día resucitó de entre los muertos; subió a los cielos y está sentado a la derecha de Dios Padre todopoderoso.</a:t>
-            </a:r>
-          </a:p>
-          <a:p>
-            <a:pPr>
-              <a:lnSpc>
-                <a:spcPct val="115000"/>
-              </a:lnSpc>
-            </a:pPr>
-            <a:r>
-              <a:rPr b="0" sz="2000">
-                <a:solidFill>
-                  <a:srgbClr val="37352F"/>
-                </a:solidFill>
-              </a:rPr>
-              <a:t>Desde allí ha de venir a juzgar a vivos y muertos.</a:t>
-            </a:r>
-          </a:p>
-          <a:p>
-            <a:pPr>
-              <a:lnSpc>
-                <a:spcPct val="115000"/>
-              </a:lnSpc>
-            </a:pPr>
-            <a:r>
-              <a:rPr b="0" sz="2000">
-                <a:solidFill>
-                  <a:srgbClr val="37352F"/>
-                </a:solidFill>
-              </a:rPr>
-              <a:t>Creo en el Espíritu Santo, la santa Iglesia católica, la comunión de los santos, el perdón de los pecados, la resurrección de la carne y la vida eterna. Amén.</a:t>
+                <a:spcPct val="105000"/>
+              </a:lnSpc>
+            </a:pPr>
+            <a:r>
+              <a:rPr b="0" sz="1900">
+                <a:solidFill>
+                  <a:srgbClr val="37352F"/>
+                </a:solidFill>
+              </a:rPr>
+              <a:t>¿Qué te puedo dar que no me hayas dado Tú?</a:t>
+            </a:r>
+          </a:p>
+          <a:p>
+            <a:pPr>
+              <a:lnSpc>
+                <a:spcPct val="105000"/>
+              </a:lnSpc>
+            </a:pPr>
+            <a:r>
+              <a:rPr b="0" sz="1900">
+                <a:solidFill>
+                  <a:srgbClr val="37352F"/>
+                </a:solidFill>
+              </a:rPr>
+              <a:t>¿Qué te puedo decir que no me hayas dicho Tú?</a:t>
+            </a:r>
+          </a:p>
+          <a:p>
+            <a:pPr>
+              <a:lnSpc>
+                <a:spcPct val="105000"/>
+              </a:lnSpc>
+            </a:pPr>
+            <a:r>
+              <a:rPr b="0" sz="1900">
+                <a:solidFill>
+                  <a:srgbClr val="37352F"/>
+                </a:solidFill>
+              </a:rPr>
+              <a:t>¿Qué puedo hacer por ti, si yo no puedo hacer nada?</a:t>
+            </a:r>
+          </a:p>
+          <a:p>
+            <a:pPr>
+              <a:lnSpc>
+                <a:spcPct val="105000"/>
+              </a:lnSpc>
+            </a:pPr>
+            <a:r>
+              <a:rPr b="0" sz="1900">
+                <a:solidFill>
+                  <a:srgbClr val="37352F"/>
+                </a:solidFill>
+              </a:rPr>
+              <a:t>Si yo no puedo hacer nada si no es por ti, mi Dios.</a:t>
+            </a:r>
+          </a:p>
+          <a:p>
+            <a:pPr>
+              <a:lnSpc>
+                <a:spcPct val="105000"/>
+              </a:lnSpc>
+            </a:pPr>
+            <a:r>
+              <a:rPr b="1" sz="1900">
+                <a:solidFill>
+                  <a:srgbClr val="37352F"/>
+                </a:solidFill>
+              </a:rPr>
+              <a:t>TODO LO QUE SE, TODO LO QUE SOY,</a:t>
+            </a:r>
+          </a:p>
+          <a:p>
+            <a:pPr>
+              <a:lnSpc>
+                <a:spcPct val="105000"/>
+              </a:lnSpc>
+            </a:pPr>
+            <a:r>
+              <a:rPr b="0" sz="1900">
+                <a:solidFill>
+                  <a:srgbClr val="37352F"/>
+                </a:solidFill>
+              </a:rPr>
+              <a:t>TODO LO QUE TENGO ES TUYO (bis)</a:t>
             </a:r>
           </a:p>
         </p:txBody>
@@ -4052,7 +4101,7 @@
       </p:pic>
       <p:pic>
         <p:nvPicPr>
-          <p:cNvPr id="4" name="Picture 3" descr="fano_20140880_dadles_vosotros_de_comer.jpg"/>
+          <p:cNvPr id="4" name="Picture 3" descr="fano_20140896_ii_domingo_de_adviento_dile_sí.jpg"/>
           <p:cNvPicPr>
             <a:picLocks noChangeAspect="1"/>
           </p:cNvPicPr>
@@ -4067,7 +4116,7 @@
         <p:spPr>
           <a:xfrm>
             <a:off x="6675120" y="1005840"/>
-            <a:ext cx="3213791" cy="2560320"/>
+            <a:ext cx="4334278" cy="2560320"/>
           </a:xfrm>
           <a:prstGeom prst="rect">
             <a:avLst/>
@@ -4190,7 +4239,7 @@
                   <a:srgbClr val="7C3AED"/>
                 </a:solidFill>
               </a:rPr>
-              <a:t>OFERTORIO</a:t>
+              <a:t>SANTO</a:t>
             </a:r>
           </a:p>
           <a:p>
@@ -4200,7 +4249,7 @@
                   <a:srgbClr val="7C3AED"/>
                 </a:solidFill>
               </a:rPr>
-              <a:t>PADRE NUESTRO DE LA VIDA</a:t>
+              <a:t>SANTO JESUITA</a:t>
             </a:r>
           </a:p>
           <a:p>
@@ -4220,12 +4269,60 @@
               </a:lnSpc>
             </a:pPr>
             <a:r>
+              <a:rPr b="1" sz="1900">
+                <a:solidFill>
+                  <a:srgbClr val="37352F"/>
+                </a:solidFill>
+              </a:rPr>
+              <a:t>SANTO, SANTO, SANTO-O-O,</a:t>
+            </a:r>
+            <a:r>
               <a:rPr b="0" sz="1900">
                 <a:solidFill>
                   <a:srgbClr val="37352F"/>
                 </a:solidFill>
               </a:rPr>
-              <a:t>Padre nuestro de la vida, mío, de ése y de aquél que vive en toda criatura y ellos así han de creer.</a:t>
+              <a:t> </a:t>
+            </a:r>
+            <a:r>
+              <a:rPr b="1" sz="1900">
+                <a:solidFill>
+                  <a:srgbClr val="37352F"/>
+                </a:solidFill>
+              </a:rPr>
+              <a:t>SANTO ES EL SEÑOR,</a:t>
+            </a:r>
+            <a:r>
+              <a:rPr b="0" sz="1900">
+                <a:solidFill>
+                  <a:srgbClr val="37352F"/>
+                </a:solidFill>
+              </a:rPr>
+              <a:t> </a:t>
+            </a:r>
+            <a:r>
+              <a:rPr b="1" sz="1900">
+                <a:solidFill>
+                  <a:srgbClr val="37352F"/>
+                </a:solidFill>
+              </a:rPr>
+              <a:t>DIOS DEL UNIVERSO-O,</a:t>
+            </a:r>
+            <a:r>
+              <a:rPr b="0" sz="1900">
+                <a:solidFill>
+                  <a:srgbClr val="37352F"/>
+                </a:solidFill>
+              </a:rPr>
+              <a:t> </a:t>
+            </a:r>
+            <a:r>
+              <a:rPr b="1" sz="1900">
+                <a:solidFill>
+                  <a:srgbClr val="37352F"/>
+                </a:solidFill>
+              </a:rPr>
+              <a:t>DIOS DEL UNIVERSO-O (bis) </a:t>
             </a:r>
           </a:p>
           <a:p>
@@ -4240,7 +4337,7 @@
                   <a:srgbClr val="37352F"/>
                 </a:solidFill>
               </a:rPr>
-              <a:t>Quisiera realzar tu nombre viviendo aquí bajo el sol tu mensaje de aquel monte</a:t>
+              <a:t>Llenos están el cielo y la tierra de tu gloria.</a:t>
             </a:r>
           </a:p>
           <a:p>
@@ -4255,7 +4352,7 @@
                   <a:srgbClr val="37352F"/>
                 </a:solidFill>
               </a:rPr>
-              <a:t>SiM7m Mim de pobreza, paz y amor.</a:t>
+              <a:t>Hosanna en el cielo-o, hosanna en el cielo-o.</a:t>
             </a:r>
           </a:p>
           <a:p>
@@ -4270,7 +4367,7 @@
                   <a:srgbClr val="37352F"/>
                 </a:solidFill>
               </a:rPr>
-              <a:t>Danos pan para vivir sólo el momento presente ya que el día de mañana quizás aquí no me encuentre.</a:t>
+              <a:t>Bendito el que viene en nombre del Señor.</a:t>
             </a:r>
           </a:p>
           <a:p>
@@ -4285,7 +4382,7 @@
                   <a:srgbClr val="37352F"/>
                 </a:solidFill>
               </a:rPr>
-              <a:t>No mires lo que hice mal que yo no veré a mi deudor y en mi camino hacia ti</a:t>
+              <a:t>Hosanna en el cielo-o, hosanna en el cielo-o.</a:t>
             </a:r>
           </a:p>
           <a:p>
@@ -4295,12 +4392,12 @@
               </a:lnSpc>
             </a:pPr>
             <a:r>
-              <a:rPr b="0" sz="1900">
-                <a:solidFill>
-                  <a:srgbClr val="37352F"/>
-                </a:solidFill>
-              </a:rPr>
-              <a:t>SiM7m Mim que no caiga en tentación.</a:t>
+              <a:rPr b="1" sz="1900">
+                <a:solidFill>
+                  <a:srgbClr val="37352F"/>
+                </a:solidFill>
+              </a:rPr>
+              <a:t>SANTO, SANTO,SANTO-O-O..</a:t>
             </a:r>
           </a:p>
           <a:p>
@@ -4310,12 +4407,12 @@
               </a:lnSpc>
             </a:pPr>
             <a:r>
-              <a:rPr b="0" sz="1900">
-                <a:solidFill>
-                  <a:srgbClr val="37352F"/>
-                </a:solidFill>
-              </a:rPr>
-              <a:t>Amén, amén, que no caiga en tentación.</a:t>
+              <a:rPr b="1" sz="1900">
+                <a:solidFill>
+                  <a:srgbClr val="37352F"/>
+                </a:solidFill>
+              </a:rPr>
+              <a:t>SANTO, SANTO, SANTO-O-O,</a:t>
             </a:r>
           </a:p>
           <a:p>
@@ -4325,27 +4422,12 @@
               </a:lnSpc>
             </a:pPr>
             <a:r>
-              <a:rPr b="0" sz="1900">
-                <a:solidFill>
-                  <a:srgbClr val="37352F"/>
-                </a:solidFill>
-              </a:rPr>
-              <a:t>SiM7m Mim Amén, amén, que sea así siempre</a:t>
-            </a:r>
-          </a:p>
-          <a:p>
-            <a:pPr>
-              <a:lnSpc>
-                <a:spcPct val="105000"/>
-              </a:lnSpc>
-            </a:pPr>
-            <a:r>
-              <a:rPr b="0" sz="1900">
-                <a:solidFill>
-                  <a:srgbClr val="37352F"/>
-                </a:solidFill>
-              </a:rPr>
-              <a:t>Señor.</a:t>
+              <a:rPr b="1" sz="1900">
+                <a:solidFill>
+                  <a:srgbClr val="37352F"/>
+                </a:solidFill>
+              </a:rPr>
+              <a:t>SANTO ES EL SEÑOR.</a:t>
             </a:r>
           </a:p>
         </p:txBody>
@@ -4445,7 +4527,7 @@
       </p:pic>
       <p:pic>
         <p:nvPicPr>
-          <p:cNvPr id="4" name="Picture 3" descr="fano_20140896_ii_domingo_de_adviento_dile_sí.jpg"/>
+          <p:cNvPr id="4" name="Picture 3" descr="fano_20140634_pide_con_insistencia_a_papá_somos_sus_niños_mimados.jpg"/>
           <p:cNvPicPr>
             <a:picLocks noChangeAspect="1"/>
           </p:cNvPicPr>
@@ -4460,7 +4542,7 @@
         <p:spPr>
           <a:xfrm>
             <a:off x="6675120" y="1005840"/>
-            <a:ext cx="4334278" cy="2560320"/>
+            <a:ext cx="3017353" cy="2560320"/>
           </a:xfrm>
           <a:prstGeom prst="rect">
             <a:avLst/>
@@ -4583,7 +4665,7 @@
                   <a:srgbClr val="7C3AED"/>
                 </a:solidFill>
               </a:rPr>
-              <a:t>SANTO</a:t>
+              <a:t>PADRE NUESTRO</a:t>
             </a:r>
           </a:p>
           <a:p>
@@ -4593,7 +4675,7 @@
                   <a:srgbClr val="7C3AED"/>
                 </a:solidFill>
               </a:rPr>
-              <a:t>QUIERO HACER LO MISMO</a:t>
+              <a:t>PADRE NUESTRO</a:t>
             </a:r>
           </a:p>
           <a:p>
@@ -4618,322 +4700,7 @@
                   <a:srgbClr val="37352F"/>
                 </a:solidFill>
               </a:rPr>
-              <a:t>Es un sueño escondido del</a:t>
-            </a:r>
-          </a:p>
-          <a:p>
-            <a:pPr>
-              <a:lnSpc>
-                <a:spcPct val="105000"/>
-              </a:lnSpc>
-            </a:pPr>
-            <a:r>
-              <a:rPr b="0" sz="1900">
-                <a:solidFill>
-                  <a:srgbClr val="37352F"/>
-                </a:solidFill>
-              </a:rPr>
-              <a:t>Señor, aunque ni él mismo lo sabe.</a:t>
-            </a:r>
-          </a:p>
-          <a:p>
-            <a:pPr>
-              <a:lnSpc>
-                <a:spcPct val="105000"/>
-              </a:lnSpc>
-            </a:pPr>
-            <a:r>
-              <a:rPr b="0" sz="1900">
-                <a:solidFill>
-                  <a:srgbClr val="37352F"/>
-                </a:solidFill>
-              </a:rPr>
-              <a:t>Él es un diamante, él es lo mejor, aunque nadie se lo crea.</a:t>
-            </a:r>
-          </a:p>
-          <a:p>
-            <a:pPr>
-              <a:lnSpc>
-                <a:spcPct val="105000"/>
-              </a:lnSpc>
-            </a:pPr>
-            <a:r>
-              <a:rPr b="0" sz="1900">
-                <a:solidFill>
-                  <a:srgbClr val="37352F"/>
-                </a:solidFill>
-              </a:rPr>
-              <a:t>Señor, haz que alguien sí lo crea.</a:t>
-            </a:r>
-          </a:p>
-          <a:p>
-            <a:pPr>
-              <a:lnSpc>
-                <a:spcPct val="105000"/>
-              </a:lnSpc>
-            </a:pPr>
-            <a:r>
-              <a:rPr b="0" sz="1900">
-                <a:solidFill>
-                  <a:srgbClr val="37352F"/>
-                </a:solidFill>
-              </a:rPr>
-              <a:t>José sólo buscaba un puesto mejor:</a:t>
-            </a:r>
-          </a:p>
-          <a:p>
-            <a:pPr>
-              <a:lnSpc>
-                <a:spcPct val="105000"/>
-              </a:lnSpc>
-            </a:pPr>
-            <a:r>
-              <a:rPr b="0" sz="1900">
-                <a:solidFill>
-                  <a:srgbClr val="37352F"/>
-                </a:solidFill>
-              </a:rPr>
-              <a:t>tener, poder, valer… ya sabes.</a:t>
-            </a:r>
-          </a:p>
-          <a:p>
-            <a:pPr>
-              <a:lnSpc>
-                <a:spcPct val="105000"/>
-              </a:lnSpc>
-            </a:pPr>
-            <a:r>
-              <a:rPr b="0" sz="1900">
-                <a:solidFill>
-                  <a:srgbClr val="37352F"/>
-                </a:solidFill>
-              </a:rPr>
-              <a:t>En Roma tocaste su corazón, hiciste que él lo creyera, y dio por él la vida entera.</a:t>
-            </a:r>
-          </a:p>
-          <a:p>
-            <a:pPr>
-              <a:lnSpc>
-                <a:spcPct val="105000"/>
-              </a:lnSpc>
-            </a:pPr>
-            <a:r>
-              <a:rPr b="1" sz="1900">
-                <a:solidFill>
-                  <a:srgbClr val="37352F"/>
-                </a:solidFill>
-              </a:rPr>
-              <a:t>QUIERO HACER LO MISMO:</a:t>
-            </a:r>
-          </a:p>
-          <a:p>
-            <a:pPr>
-              <a:lnSpc>
-                <a:spcPct val="105000"/>
-              </a:lnSpc>
-            </a:pPr>
-            <a:r>
-              <a:rPr b="1" sz="1900">
-                <a:solidFill>
-                  <a:srgbClr val="37352F"/>
-                </a:solidFill>
-              </a:rPr>
-              <a:t>VER EN UN NIÑO UN TESORO QUE HAY QUE CUIDAR.</a:t>
-            </a:r>
-          </a:p>
-          <a:p>
-            <a:pPr>
-              <a:lnSpc>
-                <a:spcPct val="105000"/>
-              </a:lnSpc>
-            </a:pPr>
-            <a:r>
-              <a:rPr b="1" sz="1900">
-                <a:solidFill>
-                  <a:srgbClr val="37352F"/>
-                </a:solidFill>
-              </a:rPr>
-              <a:t>QUIERO ANDAR LOS PASOS</a:t>
-            </a:r>
-          </a:p>
-          <a:p>
-            <a:pPr>
-              <a:lnSpc>
-                <a:spcPct val="105000"/>
-              </a:lnSpc>
-            </a:pPr>
-            <a:r>
-              <a:rPr b="1" sz="1900">
-                <a:solidFill>
-                  <a:srgbClr val="37352F"/>
-                </a:solidFill>
-              </a:rPr>
-              <a:t>DEL SANTO VIEJO Y AMARLOS COMO LOS AMÓ CALASANZ.</a:t>
-            </a:r>
-          </a:p>
-          <a:p>
-            <a:pPr>
-              <a:lnSpc>
-                <a:spcPct val="105000"/>
-              </a:lnSpc>
-            </a:pPr>
-            <a:r>
-              <a:rPr b="0" sz="1900">
-                <a:solidFill>
-                  <a:srgbClr val="37352F"/>
-                </a:solidFill>
-              </a:rPr>
-              <a:t>Hoy aún hay millones de niños que viven la vida aplastados.</a:t>
-            </a:r>
-          </a:p>
-          <a:p>
-            <a:pPr>
-              <a:lnSpc>
-                <a:spcPct val="105000"/>
-              </a:lnSpc>
-            </a:pPr>
-            <a:r>
-              <a:rPr b="0" sz="1900">
-                <a:solidFill>
-                  <a:srgbClr val="37352F"/>
-                </a:solidFill>
-              </a:rPr>
-              <a:t>No dejes que la obra de</a:t>
-            </a:r>
-          </a:p>
-          <a:p>
-            <a:pPr>
-              <a:lnSpc>
-                <a:spcPct val="105000"/>
-              </a:lnSpc>
-            </a:pPr>
-            <a:r>
-              <a:rPr b="0" sz="1900">
-                <a:solidFill>
-                  <a:srgbClr val="37352F"/>
-                </a:solidFill>
-              </a:rPr>
-              <a:t>Calasanz se cruce nunca de brazos, que aún hay muchos niños llorando.</a:t>
-            </a:r>
-          </a:p>
-          <a:p>
-            <a:pPr>
-              <a:lnSpc>
-                <a:spcPct val="105000"/>
-              </a:lnSpc>
-            </a:pPr>
-            <a:r>
-              <a:rPr b="1" sz="1900">
-                <a:solidFill>
-                  <a:srgbClr val="37352F"/>
-                </a:solidFill>
-              </a:rPr>
-              <a:t>QUIERO HACER LO MISMO…</a:t>
-            </a:r>
-          </a:p>
-          <a:p>
-            <a:pPr>
-              <a:lnSpc>
-                <a:spcPct val="105000"/>
-              </a:lnSpc>
-            </a:pPr>
-            <a:r>
-              <a:rPr b="0" sz="1900">
-                <a:solidFill>
-                  <a:srgbClr val="37352F"/>
-                </a:solidFill>
-              </a:rPr>
-              <a:t>Yo me pondré junto a él de rodillas y buscaré dentro de sus ojos la luz.</a:t>
-            </a:r>
-          </a:p>
-          <a:p>
-            <a:pPr>
-              <a:lnSpc>
-                <a:spcPct val="105000"/>
-              </a:lnSpc>
-            </a:pPr>
-            <a:r>
-              <a:rPr b="0" sz="1900">
-                <a:solidFill>
-                  <a:srgbClr val="37352F"/>
-                </a:solidFill>
-              </a:rPr>
-              <a:t>Le ayudaré con letras y piedad a vivir</a:t>
-            </a:r>
-          </a:p>
-          <a:p>
-            <a:pPr>
-              <a:lnSpc>
-                <a:spcPct val="105000"/>
-              </a:lnSpc>
-            </a:pPr>
-            <a:r>
-              <a:rPr b="0" sz="1900">
-                <a:solidFill>
-                  <a:srgbClr val="37352F"/>
-                </a:solidFill>
-              </a:rPr>
-              <a:t>Y él sentirá que lo estoy amando, descubrirá que nació para ser feliz, y cambiará el mundo a golpes de amor por ti.</a:t>
-            </a:r>
-          </a:p>
-          <a:p>
-            <a:pPr>
-              <a:lnSpc>
-                <a:spcPct val="105000"/>
-              </a:lnSpc>
-            </a:pPr>
-            <a:r>
-              <a:rPr b="1" sz="1900">
-                <a:solidFill>
-                  <a:srgbClr val="37352F"/>
-                </a:solidFill>
-              </a:rPr>
-              <a:t>QUIERO HACER LO MISMO… (2)</a:t>
-            </a:r>
-          </a:p>
-          <a:p>
-            <a:pPr>
-              <a:lnSpc>
-                <a:spcPct val="105000"/>
-              </a:lnSpc>
-            </a:pPr>
-            <a:r>
-              <a:rPr b="0" sz="1900">
-                <a:solidFill>
-                  <a:srgbClr val="37352F"/>
-                </a:solidFill>
-              </a:rPr>
-              <a:t>Yo me pondré junto a él de rodillas… y cambiará el mundo a golpes de amor por ti.</a:t>
-            </a:r>
-          </a:p>
-          <a:p>
-            <a:pPr>
-              <a:lnSpc>
-                <a:spcPct val="105000"/>
-              </a:lnSpc>
-            </a:pPr>
-            <a:r>
-              <a:rPr b="0" sz="1900">
-                <a:solidFill>
-                  <a:srgbClr val="37352F"/>
-                </a:solidFill>
-              </a:rPr>
-              <a:t>Con letras y piedad a vivir.</a:t>
-            </a:r>
-          </a:p>
-          <a:p>
-            <a:pPr>
-              <a:lnSpc>
-                <a:spcPct val="105000"/>
-              </a:lnSpc>
-            </a:pPr>
-            <a:r>
-              <a:rPr b="0" sz="1900">
-                <a:solidFill>
-                  <a:srgbClr val="37352F"/>
-                </a:solidFill>
-              </a:rPr>
-              <a:t>Re-Sol Porque nació para ser feliz.</a:t>
+              <a:t>Rellenar a mano</a:t>
             </a:r>
           </a:p>
         </p:txBody>
@@ -5033,7 +4800,7 @@
       </p:pic>
       <p:pic>
         <p:nvPicPr>
-          <p:cNvPr id="4" name="Picture 3" descr="fano_20140634_pide_con_insistencia_a_papá_somos_sus_niños_mimados.jpg"/>
+          <p:cNvPr id="4" name="Picture 3" descr="fano_20140408_arranca_lo_que_te_impida_dar_frutos_de_amor_domingo_27_de_se.jpg"/>
           <p:cNvPicPr>
             <a:picLocks noChangeAspect="1"/>
           </p:cNvPicPr>
@@ -5048,7 +4815,7 @@
         <p:spPr>
           <a:xfrm>
             <a:off x="6675120" y="1005840"/>
-            <a:ext cx="3017353" cy="2560320"/>
+            <a:ext cx="2636485" cy="2560320"/>
           </a:xfrm>
           <a:prstGeom prst="rect">
             <a:avLst/>
@@ -5171,7 +4938,7 @@
                   <a:srgbClr val="7C3AED"/>
                 </a:solidFill>
               </a:rPr>
-              <a:t>PADRE NUESTRO</a:t>
+              <a:t>RITO DE LA PAZ</a:t>
             </a:r>
           </a:p>
           <a:p>
@@ -5181,7 +4948,7 @@
                   <a:srgbClr val="7C3AED"/>
                 </a:solidFill>
               </a:rPr>
-              <a:t>PONGO MI VIDA EN TUS MANOS</a:t>
+              <a:t>LA PAZ TE DOY</a:t>
             </a:r>
           </a:p>
           <a:p>
@@ -5206,7 +4973,7 @@
                   <a:srgbClr val="37352F"/>
                 </a:solidFill>
               </a:rPr>
-              <a:t>Pongo mi vida en tus manos,</a:t>
+              <a:t>La paz te doy a ti, mi hermano, la paz que Dios me regaló, y en un abrazo a ti te entrego la paz que llevo en mi corazón. (bis)</a:t>
             </a:r>
           </a:p>
           <a:p>
@@ -5221,52 +4988,7 @@
                   <a:srgbClr val="37352F"/>
                 </a:solidFill>
               </a:rPr>
-              <a:t>Padre mío me abandono a ti.</a:t>
-            </a:r>
-          </a:p>
-          <a:p>
-            <a:pPr>
-              <a:lnSpc>
-                <a:spcPct val="105000"/>
-              </a:lnSpc>
-            </a:pPr>
-            <a:r>
-              <a:rPr b="0" sz="1900">
-                <a:solidFill>
-                  <a:srgbClr val="37352F"/>
-                </a:solidFill>
-              </a:rPr>
-              <a:t>Haz de mi lo que quieras estoy dispuesto a aceptarlo todo...</a:t>
-            </a:r>
-          </a:p>
-          <a:p>
-            <a:pPr>
-              <a:lnSpc>
-                <a:spcPct val="105000"/>
-              </a:lnSpc>
-            </a:pPr>
-            <a:r>
-              <a:rPr b="0" sz="1900">
-                <a:solidFill>
-                  <a:srgbClr val="37352F"/>
-                </a:solidFill>
-              </a:rPr>
-              <a:t>(3)</a:t>
-            </a:r>
-          </a:p>
-          <a:p>
-            <a:pPr>
-              <a:lnSpc>
-                <a:spcPct val="105000"/>
-              </a:lnSpc>
-            </a:pPr>
-            <a:r>
-              <a:rPr b="0" sz="1900">
-                <a:solidFill>
-                  <a:srgbClr val="37352F"/>
-                </a:solidFill>
-              </a:rPr>
-              <a:t>... con infinita confianza porque tú eres mi Padre.</a:t>
+              <a:t>Recíbela, recíbela, esta es la paz que el mundo no te puede dar. (bis)</a:t>
             </a:r>
           </a:p>
         </p:txBody>
@@ -5366,7 +5088,7 @@
       </p:pic>
       <p:pic>
         <p:nvPicPr>
-          <p:cNvPr id="4" name="Picture 3" descr="fano_20140408_arranca_lo_que_te_impida_dar_frutos_de_amor_domingo_27_de_se.jpg"/>
+          <p:cNvPr id="4" name="Picture 3" descr="fano_20140959_el_que_come_este_pan_vivirá_para_siempre.jpg"/>
           <p:cNvPicPr>
             <a:picLocks noChangeAspect="1"/>
           </p:cNvPicPr>
@@ -5381,7 +5103,7 @@
         <p:spPr>
           <a:xfrm>
             <a:off x="6675120" y="1005840"/>
-            <a:ext cx="2636485" cy="2560320"/>
+            <a:ext cx="2991028" cy="2560320"/>
           </a:xfrm>
           <a:prstGeom prst="rect">
             <a:avLst/>
@@ -5504,7 +5226,7 @@
                   <a:srgbClr val="7C3AED"/>
                 </a:solidFill>
               </a:rPr>
-              <a:t>RITO DE LA PAZ</a:t>
+              <a:t>COMUNIÓN</a:t>
             </a:r>
           </a:p>
           <a:p>
@@ -5514,7 +5236,7 @@
                   <a:srgbClr val="7C3AED"/>
                 </a:solidFill>
               </a:rPr>
-              <a:t>UNA NUEVA ESPERANZA</a:t>
+              <a:t>BENDIGAMOS AL SEÑOR</a:t>
             </a:r>
           </a:p>
           <a:p>
@@ -5539,7 +5261,7 @@
                   <a:srgbClr val="37352F"/>
                 </a:solidFill>
               </a:rPr>
-              <a:t>Una nueva esperanza empieza en mí a nacer, me hablas del amor y casi sin darme cuenta mi corazón empieza a entusiasmarse y a comprender lo que es vivir.</a:t>
+              <a:t>Bendigamos al Señor, Dios de toda la creación por habernos regalado su amor.</a:t>
             </a:r>
           </a:p>
           <a:p>
@@ -5549,12 +5271,27 @@
               </a:lnSpc>
             </a:pPr>
             <a:r>
+              <a:rPr b="0" sz="1900">
+                <a:solidFill>
+                  <a:srgbClr val="37352F"/>
+                </a:solidFill>
+              </a:rPr>
+              <a:t>Su bondad y su perdón, y su gran fidelidad por los siglos de los siglos durará.</a:t>
+            </a:r>
+          </a:p>
+          <a:p>
+            <a:pPr>
+              <a:lnSpc>
+                <a:spcPct val="105000"/>
+              </a:lnSpc>
+            </a:pPr>
+            <a:r>
               <a:rPr b="1" sz="1900">
                 <a:solidFill>
                   <a:srgbClr val="37352F"/>
                 </a:solidFill>
               </a:rPr>
-              <a:t>TÚ ALUMBRAS MI CAMINO</a:t>
+              <a:t>EL ESPÍRITU DE DIOS HOY ESTÁ SOBRE MI.</a:t>
             </a:r>
           </a:p>
           <a:p>
@@ -5569,7 +5306,7 @@
                   <a:srgbClr val="37352F"/>
                 </a:solidFill>
               </a:rPr>
-              <a:t>CON TUS PALABRAS,</a:t>
+              <a:t>ÉL ES QUIEN ME HA UNGIDO A PROCLAMAR</a:t>
             </a:r>
           </a:p>
           <a:p>
@@ -5584,7 +5321,7 @@
                   <a:srgbClr val="37352F"/>
                 </a:solidFill>
               </a:rPr>
-              <a:t>PUES ELLAS JAMÁS SE BORRARÁN.</a:t>
+              <a:t>LA BUENA NUEVA A LOS MÁS POBRES,</a:t>
             </a:r>
           </a:p>
           <a:p>
@@ -5594,12 +5331,27 @@
               </a:lnSpc>
             </a:pPr>
             <a:r>
+              <a:rPr b="0" sz="1900">
+                <a:solidFill>
+                  <a:srgbClr val="37352F"/>
+                </a:solidFill>
+              </a:rPr>
+              <a:t>Sol Mim La La7 (2ª:Sol La Re)</a:t>
+            </a:r>
+          </a:p>
+          <a:p>
+            <a:pPr>
+              <a:lnSpc>
+                <a:spcPct val="105000"/>
+              </a:lnSpc>
+            </a:pPr>
+            <a:r>
               <a:rPr b="1" sz="1900">
                 <a:solidFill>
                   <a:srgbClr val="37352F"/>
                 </a:solidFill>
               </a:rPr>
-              <a:t>Y AL CAMINAR JUNTOS</a:t>
+              <a:t>LA GRACIA DE SU SALVACIÓN. (BIS)</a:t>
             </a:r>
           </a:p>
           <a:p>
@@ -5609,12 +5361,27 @@
               </a:lnSpc>
             </a:pPr>
             <a:r>
+              <a:rPr b="0" sz="1900">
+                <a:solidFill>
+                  <a:srgbClr val="37352F"/>
+                </a:solidFill>
+              </a:rPr>
+              <a:t>Enviados con poder y en el nombre de Jesús a sanar a los enfermos del dolor, a los ciegos dar visión, a los pobres la verdad y a los presos y oprimidos, libertad.</a:t>
+            </a:r>
+          </a:p>
+          <a:p>
+            <a:pPr>
+              <a:lnSpc>
+                <a:spcPct val="105000"/>
+              </a:lnSpc>
+            </a:pPr>
+            <a:r>
               <a:rPr b="1" sz="1900">
                 <a:solidFill>
                   <a:srgbClr val="37352F"/>
                 </a:solidFill>
               </a:rPr>
-              <a:t>ME BRINDAS TU AMISTAD,</a:t>
+              <a:t>Con la fuerza de su amor y de la resurrección anunciamos: llega ya la salvación.</a:t>
             </a:r>
           </a:p>
           <a:p>
@@ -5629,127 +5396,7 @@
                   <a:srgbClr val="37352F"/>
                 </a:solidFill>
               </a:rPr>
-              <a:t>EL GOZO, LA ALEGRÍA Y LA PAZ.</a:t>
-            </a:r>
-          </a:p>
-          <a:p>
-            <a:pPr>
-              <a:lnSpc>
-                <a:spcPct val="105000"/>
-              </a:lnSpc>
-            </a:pPr>
-            <a:r>
-              <a:rPr b="1" sz="1900">
-                <a:solidFill>
-                  <a:srgbClr val="37352F"/>
-                </a:solidFill>
-              </a:rPr>
-              <a:t>PUES ¿QUÉ ES VIVIR?</a:t>
-            </a:r>
-          </a:p>
-          <a:p>
-            <a:pPr>
-              <a:lnSpc>
-                <a:spcPct val="105000"/>
-              </a:lnSpc>
-            </a:pPr>
-            <a:r>
-              <a:rPr b="1" sz="1900">
-                <a:solidFill>
-                  <a:srgbClr val="37352F"/>
-                </a:solidFill>
-              </a:rPr>
-              <a:t>¡LA VIDA ES CRISTO!</a:t>
-            </a:r>
-          </a:p>
-          <a:p>
-            <a:pPr>
-              <a:lnSpc>
-                <a:spcPct val="105000"/>
-              </a:lnSpc>
-            </a:pPr>
-            <a:r>
-              <a:rPr b="1" sz="1900">
-                <a:solidFill>
-                  <a:srgbClr val="37352F"/>
-                </a:solidFill>
-              </a:rPr>
-              <a:t>Y SU AMOR MI ÚNICA GANANCIA</a:t>
-            </a:r>
-          </a:p>
-          <a:p>
-            <a:pPr>
-              <a:lnSpc>
-                <a:spcPct val="105000"/>
-              </a:lnSpc>
-            </a:pPr>
-            <a:r>
-              <a:rPr b="1" sz="1900">
-                <a:solidFill>
-                  <a:srgbClr val="37352F"/>
-                </a:solidFill>
-              </a:rPr>
-              <a:t>PUES ¿QUÉ ES VIVIR?</a:t>
-            </a:r>
-          </a:p>
-          <a:p>
-            <a:pPr>
-              <a:lnSpc>
-                <a:spcPct val="105000"/>
-              </a:lnSpc>
-            </a:pPr>
-            <a:r>
-              <a:rPr b="1" sz="1900">
-                <a:solidFill>
-                  <a:srgbClr val="37352F"/>
-                </a:solidFill>
-              </a:rPr>
-              <a:t>¡LA VIDA ES CRISTO!</a:t>
-            </a:r>
-          </a:p>
-          <a:p>
-            <a:pPr>
-              <a:lnSpc>
-                <a:spcPct val="105000"/>
-              </a:lnSpc>
-            </a:pPr>
-            <a:r>
-              <a:rPr b="1" sz="1900">
-                <a:solidFill>
-                  <a:srgbClr val="37352F"/>
-                </a:solidFill>
-              </a:rPr>
-              <a:t>Y SU AMOR ME BASTA.</a:t>
-            </a:r>
-          </a:p>
-          <a:p>
-            <a:pPr>
-              <a:lnSpc>
-                <a:spcPct val="105000"/>
-              </a:lnSpc>
-            </a:pPr>
-            <a:r>
-              <a:rPr b="0" sz="1900">
-                <a:solidFill>
-                  <a:srgbClr val="37352F"/>
-                </a:solidFill>
-              </a:rPr>
-              <a:t>Sé que mucha gente no ha logrado saber que marchas a su lado, que compartes su vida entera.</a:t>
-            </a:r>
-          </a:p>
-          <a:p>
-            <a:pPr>
-              <a:lnSpc>
-                <a:spcPct val="105000"/>
-              </a:lnSpc>
-            </a:pPr>
-            <a:r>
-              <a:rPr b="0" sz="1900">
-                <a:solidFill>
-                  <a:srgbClr val="37352F"/>
-                </a:solidFill>
-              </a:rPr>
-              <a:t>Quisiera ofrecerte lo que soy para anunciar lo que he visto en Ti.</a:t>
+              <a:t>Que ni el miedo, ni el temor, ni la duda o la opresión borrarán la paz de nuestro corazón.</a:t>
             </a:r>
           </a:p>
         </p:txBody>
@@ -5849,7 +5496,7 @@
       </p:pic>
       <p:pic>
         <p:nvPicPr>
-          <p:cNvPr id="4" name="Picture 3" descr="fano_20140959_el_que_come_este_pan_vivirá_para_siempre.jpg"/>
+          <p:cNvPr id="4" name="Picture 3" descr="fano_20140474_solemnidad_de_santa_maria_madre_de_dios_1_de_enero_de_2017_j.jpg"/>
           <p:cNvPicPr>
             <a:picLocks noChangeAspect="1"/>
           </p:cNvPicPr>
@@ -5864,7 +5511,7 @@
         <p:spPr>
           <a:xfrm>
             <a:off x="6675120" y="1005840"/>
-            <a:ext cx="2991028" cy="2560320"/>
+            <a:ext cx="3621386" cy="2560320"/>
           </a:xfrm>
           <a:prstGeom prst="rect">
             <a:avLst/>
@@ -5987,7 +5634,7 @@
                   <a:srgbClr val="7C3AED"/>
                 </a:solidFill>
               </a:rPr>
-              <a:t>COMUNIÓN</a:t>
+              <a:t>CANTO A MARÍA</a:t>
             </a:r>
           </a:p>
           <a:p>
@@ -5997,7 +5644,7 @@
                   <a:srgbClr val="7C3AED"/>
                 </a:solidFill>
               </a:rPr>
-              <a:t>TODO MI SER</a:t>
+              <a:t>A TU AMPARO Y PROTECCIÓN</a:t>
             </a:r>
           </a:p>
           <a:p>
@@ -6017,12 +5664,12 @@
               </a:lnSpc>
             </a:pPr>
             <a:r>
-              <a:rPr b="0" sz="1900">
-                <a:solidFill>
-                  <a:srgbClr val="37352F"/>
-                </a:solidFill>
-              </a:rPr>
-              <a:t>Todo mi ser, todo lo que soy te pertenece sólo a ti.</a:t>
+              <a:rPr b="1" sz="1900">
+                <a:solidFill>
+                  <a:srgbClr val="37352F"/>
+                </a:solidFill>
+              </a:rPr>
+              <a:t>A TU AMPARO Y PROTECCIÓN,</a:t>
             </a:r>
           </a:p>
           <a:p>
@@ -6032,12 +5679,12 @@
               </a:lnSpc>
             </a:pPr>
             <a:r>
-              <a:rPr b="0" sz="1900">
-                <a:solidFill>
-                  <a:srgbClr val="37352F"/>
-                </a:solidFill>
-              </a:rPr>
-              <a:t>Desde mi pobreza,</a:t>
+              <a:rPr b="1" sz="1900">
+                <a:solidFill>
+                  <a:srgbClr val="37352F"/>
+                </a:solidFill>
+              </a:rPr>
+              <a:t>MADRE DE DIOS, ACUDIMOS.</a:t>
             </a:r>
           </a:p>
           <a:p>
@@ -6047,12 +5694,12 @@
               </a:lnSpc>
             </a:pPr>
             <a:r>
-              <a:rPr b="0" sz="1900">
-                <a:solidFill>
-                  <a:srgbClr val="37352F"/>
-                </a:solidFill>
-              </a:rPr>
-              <a:t>Tú eres la fuerza.</a:t>
+              <a:rPr b="1" sz="1900">
+                <a:solidFill>
+                  <a:srgbClr val="37352F"/>
+                </a:solidFill>
+              </a:rPr>
+              <a:t>NO DESOIGAS NUESTROS RUEGOS</a:t>
             </a:r>
           </a:p>
           <a:p>
@@ -6062,12 +5709,12 @@
               </a:lnSpc>
             </a:pPr>
             <a:r>
-              <a:rPr b="0" sz="1900">
-                <a:solidFill>
-                  <a:srgbClr val="37352F"/>
-                </a:solidFill>
-              </a:rPr>
-              <a:t>Nada sé, sólo que caminaré.</a:t>
+              <a:rPr b="1" sz="1900">
+                <a:solidFill>
+                  <a:srgbClr val="37352F"/>
+                </a:solidFill>
+              </a:rPr>
+              <a:t>Y DE TODOS LOS PELIGROS,</a:t>
             </a:r>
           </a:p>
           <a:p>
@@ -6082,7 +5729,7 @@
                   <a:srgbClr val="37352F"/>
                 </a:solidFill>
               </a:rPr>
-              <a:t>LLEGASTE A MI VIDA CON TU LUZ,</a:t>
+              <a:t>VIRGEN GLORIOSA Y BENDITA,</a:t>
             </a:r>
           </a:p>
           <a:p>
@@ -6097,67 +5744,7 @@
                   <a:srgbClr val="37352F"/>
                 </a:solidFill>
               </a:rPr>
-              <a:t>CAMBIASTE MI MENTE CON TU AMOR,</a:t>
-            </a:r>
-          </a:p>
-          <a:p>
-            <a:pPr>
-              <a:lnSpc>
-                <a:spcPct val="105000"/>
-              </a:lnSpc>
-            </a:pPr>
-            <a:r>
-              <a:rPr b="1" sz="1900">
-                <a:solidFill>
-                  <a:srgbClr val="37352F"/>
-                </a:solidFill>
-              </a:rPr>
-              <a:t>VACIASTE MI ALMA Y AHORA ESTÁS</a:t>
-            </a:r>
-          </a:p>
-          <a:p>
-            <a:pPr>
-              <a:lnSpc>
-                <a:spcPct val="105000"/>
-              </a:lnSpc>
-            </a:pPr>
-            <a:r>
-              <a:rPr b="1" sz="1900">
-                <a:solidFill>
-                  <a:srgbClr val="37352F"/>
-                </a:solidFill>
-              </a:rPr>
-              <a:t>DENTRO DE MÍ.</a:t>
-            </a:r>
-          </a:p>
-          <a:p>
-            <a:pPr>
-              <a:lnSpc>
-                <a:spcPct val="105000"/>
-              </a:lnSpc>
-            </a:pPr>
-            <a:r>
-              <a:rPr b="0" sz="1900">
-                <a:solidFill>
-                  <a:srgbClr val="37352F"/>
-                </a:solidFill>
-              </a:rPr>
-              <a:t>Todo mi ser, todo lo que soy, lo bueno y lo malo la pongo a tus pies.</a:t>
-            </a:r>
-          </a:p>
-          <a:p>
-            <a:pPr>
-              <a:lnSpc>
-                <a:spcPct val="105000"/>
-              </a:lnSpc>
-            </a:pPr>
-            <a:r>
-              <a:rPr b="0" sz="1900">
-                <a:solidFill>
-                  <a:srgbClr val="37352F"/>
-                </a:solidFill>
-              </a:rPr>
-              <a:t>Aunque a veces llegues a mi templo y lo encuentres ya lleno, no es verdad, sólo se llena cuando Tú moras en él.</a:t>
+              <a:t>DEFIENDE SIEMPRE A TUS HIJOS</a:t>
             </a:r>
           </a:p>
         </p:txBody>
@@ -6257,7 +5844,7 @@
       </p:pic>
       <p:pic>
         <p:nvPicPr>
-          <p:cNvPr id="4" name="Picture 3" descr="fano_20140474_solemnidad_de_santa_maria_madre_de_dios_1_de_enero_de_2017_j.jpg"/>
+          <p:cNvPr id="4" name="Picture 3" descr="fano_20140414_la_ternura_de_los_humildes_salva_al_mundo_domingo_8_de_novie.jpg"/>
           <p:cNvPicPr>
             <a:picLocks noChangeAspect="1"/>
           </p:cNvPicPr>
@@ -6272,7 +5859,7 @@
         <p:spPr>
           <a:xfrm>
             <a:off x="6675120" y="1005840"/>
-            <a:ext cx="3621386" cy="2560320"/>
+            <a:ext cx="2168591" cy="2560320"/>
           </a:xfrm>
           <a:prstGeom prst="rect">
             <a:avLst/>
@@ -6395,7 +5982,7 @@
                   <a:srgbClr val="7C3AED"/>
                 </a:solidFill>
               </a:rPr>
-              <a:t>CANTO A MARÍA</a:t>
+              <a:t>DESPEDIDA</a:t>
             </a:r>
           </a:p>
           <a:p>
@@ -6405,7 +5992,7 @@
                   <a:srgbClr val="7C3AED"/>
                 </a:solidFill>
               </a:rPr>
-              <a:t>MARÍA, MÚSICA DE DIOS</a:t>
+              <a:t>COMO CORRE UN RÍO</a:t>
             </a:r>
           </a:p>
           <a:p>
@@ -6425,12 +6012,42 @@
               </a:lnSpc>
             </a:pPr>
             <a:r>
+              <a:rPr b="0" sz="1900">
+                <a:solidFill>
+                  <a:srgbClr val="37352F"/>
+                </a:solidFill>
+              </a:rPr>
+              <a:t>Como corre un río dentro de mi ser (x2)</a:t>
+            </a:r>
+          </a:p>
+          <a:p>
+            <a:pPr>
+              <a:lnSpc>
+                <a:spcPct val="105000"/>
+              </a:lnSpc>
+            </a:pPr>
+            <a:r>
+              <a:rPr b="0" sz="1900">
+                <a:solidFill>
+                  <a:srgbClr val="37352F"/>
+                </a:solidFill>
+              </a:rPr>
+              <a:t>así yo confío en Cristo, mi Rey (x2)</a:t>
+            </a:r>
+          </a:p>
+          <a:p>
+            <a:pPr>
+              <a:lnSpc>
+                <a:spcPct val="105000"/>
+              </a:lnSpc>
+            </a:pPr>
+            <a:r>
               <a:rPr b="1" sz="1900">
                 <a:solidFill>
                   <a:srgbClr val="37352F"/>
                 </a:solidFill>
               </a:rPr>
-              <a:t>MARÍA, MÚSICA DE DIOS</a:t>
+              <a:t>COMO UN RÍO DE AGUA VIVA,</a:t>
             </a:r>
           </a:p>
           <a:p>
@@ -6440,12 +6057,57 @@
               </a:lnSpc>
             </a:pPr>
             <a:r>
+              <a:rPr b="1" sz="1900">
+                <a:solidFill>
+                  <a:srgbClr val="37352F"/>
+                </a:solidFill>
+              </a:rPr>
+              <a:t>QUE SALTA P’ARRIBA, QUE LLEVO DENTRO</a:t>
+            </a:r>
+          </a:p>
+          <a:p>
+            <a:pPr>
+              <a:lnSpc>
+                <a:spcPct val="105000"/>
+              </a:lnSpc>
+            </a:pPr>
+            <a:r>
+              <a:rPr b="1" sz="1900">
+                <a:solidFill>
+                  <a:srgbClr val="37352F"/>
+                </a:solidFill>
+              </a:rPr>
+              <a:t>QUE AFIRMA Y CONFIRMA EN ESTE MOMENTO</a:t>
+            </a:r>
+          </a:p>
+          <a:p>
+            <a:pPr>
+              <a:lnSpc>
+                <a:spcPct val="105000"/>
+              </a:lnSpc>
+            </a:pPr>
+            <a:r>
+              <a:rPr b="1" sz="1900">
+                <a:solidFill>
+                  <a:srgbClr val="37352F"/>
+                </a:solidFill>
+              </a:rPr>
+              <a:t>EL ESPÍRITU SANTO ESTÁ VINIENDO (X2)</a:t>
+            </a:r>
+          </a:p>
+          <a:p>
+            <a:pPr>
+              <a:lnSpc>
+                <a:spcPct val="105000"/>
+              </a:lnSpc>
+            </a:pPr>
+            <a:r>
               <a:rPr b="0" sz="1900">
                 <a:solidFill>
                   <a:srgbClr val="37352F"/>
                 </a:solidFill>
               </a:rPr>
-              <a:t>Me quedé sin voz con qué cantar y mi alma vacía dormía en sequedad</a:t>
+              <a:t>Jesús está pasando por ahí</a:t>
             </a:r>
           </a:p>
           <a:p>
@@ -6460,7 +6122,7 @@
                   <a:srgbClr val="37352F"/>
                 </a:solidFill>
               </a:rPr>
-              <a:t>Y pensé para mí: me pondré en sus manos manos de Madre, me dejaré en su amor</a:t>
+              <a:t>Jesús está pasando por ahí</a:t>
             </a:r>
           </a:p>
           <a:p>
@@ -6475,7 +6137,7 @@
                   <a:srgbClr val="37352F"/>
                 </a:solidFill>
               </a:rPr>
-              <a:t>Y tú, María, házme música de Dios</a:t>
+              <a:t>Y cuando pasa todo lo transforma</a:t>
             </a:r>
           </a:p>
           <a:p>
@@ -6490,7 +6152,7 @@
                   <a:srgbClr val="37352F"/>
                 </a:solidFill>
               </a:rPr>
-              <a:t>Y tú, María, anima tú las cuerdas de mi alma</a:t>
+              <a:t>Se va la tristeza, viene la alegría</a:t>
             </a:r>
           </a:p>
           <a:p>
@@ -6505,7 +6167,7 @@
                   <a:srgbClr val="37352F"/>
                 </a:solidFill>
               </a:rPr>
-              <a:t>Aleluya, Amén Y tú, María, házme música de Dios</a:t>
+              <a:t>Y cuando pasa todo lo transforma</a:t>
             </a:r>
           </a:p>
           <a:p>
@@ -6520,7 +6182,7 @@
                   <a:srgbClr val="37352F"/>
                 </a:solidFill>
               </a:rPr>
-              <a:t>Y tú, María, anima tú las cuerdas de mi alma</a:t>
+              <a:t>Viene la alegría para ti y para mí</a:t>
             </a:r>
           </a:p>
           <a:p>
@@ -6530,102 +6192,12 @@
               </a:lnSpc>
             </a:pPr>
             <a:r>
-              <a:rPr b="0" sz="1900">
-                <a:solidFill>
-                  <a:srgbClr val="37352F"/>
-                </a:solidFill>
-              </a:rPr>
-              <a:t>Aleluya, Amén María, acompaña tú mi caminar yo sola no puedo, ayúdame a andar</a:t>
-            </a:r>
-          </a:p>
-          <a:p>
-            <a:pPr>
-              <a:lnSpc>
-                <a:spcPct val="105000"/>
-              </a:lnSpc>
-            </a:pPr>
-            <a:r>
-              <a:rPr b="0" sz="1900">
-                <a:solidFill>
-                  <a:srgbClr val="37352F"/>
-                </a:solidFill>
-              </a:rPr>
-              <a:t>Y pensé para mí: me pondré en sus manos manos de Madre, me dejaré en su amor</a:t>
-            </a:r>
-          </a:p>
-          <a:p>
-            <a:pPr>
-              <a:lnSpc>
-                <a:spcPct val="105000"/>
-              </a:lnSpc>
-            </a:pPr>
-            <a:r>
-              <a:rPr b="0" sz="1900">
-                <a:solidFill>
-                  <a:srgbClr val="37352F"/>
-                </a:solidFill>
-              </a:rPr>
-              <a:t>Y tú, María, házme música de Dios</a:t>
-            </a:r>
-          </a:p>
-          <a:p>
-            <a:pPr>
-              <a:lnSpc>
-                <a:spcPct val="105000"/>
-              </a:lnSpc>
-            </a:pPr>
-            <a:r>
-              <a:rPr b="0" sz="1900">
-                <a:solidFill>
-                  <a:srgbClr val="37352F"/>
-                </a:solidFill>
-              </a:rPr>
-              <a:t>Y tú, María, anima tú las cuerdas de mi alma</a:t>
-            </a:r>
-          </a:p>
-          <a:p>
-            <a:pPr>
-              <a:lnSpc>
-                <a:spcPct val="105000"/>
-              </a:lnSpc>
-            </a:pPr>
-            <a:r>
-              <a:rPr b="0" sz="1900">
-                <a:solidFill>
-                  <a:srgbClr val="37352F"/>
-                </a:solidFill>
-              </a:rPr>
-              <a:t>Aleluya, Amén Y tú, María, házme música de Dios</a:t>
-            </a:r>
-          </a:p>
-          <a:p>
-            <a:pPr>
-              <a:lnSpc>
-                <a:spcPct val="105000"/>
-              </a:lnSpc>
-            </a:pPr>
-            <a:r>
-              <a:rPr b="0" sz="1900">
-                <a:solidFill>
-                  <a:srgbClr val="37352F"/>
-                </a:solidFill>
-              </a:rPr>
-              <a:t>Y tú, María, anima tú las cuerdas de mi alma</a:t>
-            </a:r>
-          </a:p>
-          <a:p>
-            <a:pPr>
-              <a:lnSpc>
-                <a:spcPct val="105000"/>
-              </a:lnSpc>
-            </a:pPr>
-            <a:r>
-              <a:rPr b="0" sz="1900">
-                <a:solidFill>
-                  <a:srgbClr val="37352F"/>
-                </a:solidFill>
-              </a:rPr>
-              <a:t>Aleluya, Amén</a:t>
+              <a:rPr b="1" sz="1900">
+                <a:solidFill>
+                  <a:srgbClr val="37352F"/>
+                </a:solidFill>
+              </a:rPr>
+              <a:t>COMO UN RÍO DE AGUA VIVA… (X2)</a:t>
             </a:r>
           </a:p>
         </p:txBody>
@@ -6639,744 +6211,6 @@
 </file>
 
 <file path=ppt/slides/slide18.xml><?xml version="1.0" encoding="utf-8"?>
-<p:sld xmlns:a="http://schemas.openxmlformats.org/drawingml/2006/main" xmlns:p="http://schemas.openxmlformats.org/presentationml/2006/main" xmlns:r="http://schemas.openxmlformats.org/officeDocument/2006/relationships">
-  <p:cSld>
-    <p:bg>
-      <p:bgPr>
-        <a:solidFill>
-          <a:srgbClr val="FAF5FF"/>
-        </a:solidFill>
-        <a:effectLst/>
-      </p:bgPr>
-    </p:bg>
-    <p:spTree>
-      <p:nvGrpSpPr>
-        <p:cNvPr id="1" name=""/>
-        <p:cNvGrpSpPr/>
-        <p:nvPr/>
-      </p:nvGrpSpPr>
-      <p:grpSpPr/>
-      <p:sp>
-        <p:nvSpPr>
-          <p:cNvPr id="2" name="Rectangle 1"/>
-          <p:cNvSpPr/>
-          <p:nvPr/>
-        </p:nvSpPr>
-        <p:spPr>
-          <a:xfrm>
-            <a:off x="0" y="0"/>
-            <a:ext cx="12193200" cy="109728"/>
-          </a:xfrm>
-          <a:prstGeom prst="rect">
-            <a:avLst/>
-          </a:prstGeom>
-          <a:solidFill>
-            <a:srgbClr val="7C3AED"/>
-          </a:solidFill>
-          <a:ln>
-            <a:noFill/>
-          </a:ln>
-        </p:spPr>
-        <p:style>
-          <a:lnRef idx="1">
-            <a:schemeClr val="accent1"/>
-          </a:lnRef>
-          <a:fillRef idx="3">
-            <a:schemeClr val="accent1"/>
-          </a:fillRef>
-          <a:effectRef idx="2">
-            <a:schemeClr val="accent1"/>
-          </a:effectRef>
-          <a:fontRef idx="minor">
-            <a:schemeClr val="lt1"/>
-          </a:fontRef>
-        </p:style>
-        <p:txBody>
-          <a:bodyPr rtlCol="0" anchor="ctr"/>
-          <a:lstStyle/>
-          <a:p>
-            <a:pPr algn="ctr"/>
-          </a:p>
-        </p:txBody>
-      </p:sp>
-      <p:pic>
-        <p:nvPicPr>
-          <p:cNvPr id="3" name="Picture 2" descr="lema_somos_uno.jpg"/>
-          <p:cNvPicPr>
-            <a:picLocks noChangeAspect="1"/>
-          </p:cNvPicPr>
-          <p:nvPr/>
-        </p:nvPicPr>
-        <p:blipFill>
-          <a:blip r:embed="rId2"/>
-          <a:stretch>
-            <a:fillRect/>
-          </a:stretch>
-        </p:blipFill>
-        <p:spPr>
-          <a:xfrm>
-            <a:off x="365760" y="8276220"/>
-            <a:ext cx="1281869" cy="685800"/>
-          </a:xfrm>
-          <a:prstGeom prst="rect">
-            <a:avLst/>
-          </a:prstGeom>
-        </p:spPr>
-      </p:pic>
-      <p:pic>
-        <p:nvPicPr>
-          <p:cNvPr id="4" name="Picture 3" descr="fano_20140414_la_ternura_de_los_humildes_salva_al_mundo_domingo_8_de_novie.jpg"/>
-          <p:cNvPicPr>
-            <a:picLocks noChangeAspect="1"/>
-          </p:cNvPicPr>
-          <p:nvPr/>
-        </p:nvPicPr>
-        <p:blipFill>
-          <a:blip r:embed="rId3"/>
-          <a:stretch>
-            <a:fillRect/>
-          </a:stretch>
-        </p:blipFill>
-        <p:spPr>
-          <a:xfrm>
-            <a:off x="6675120" y="1005840"/>
-            <a:ext cx="2168591" cy="2560320"/>
-          </a:xfrm>
-          <a:prstGeom prst="rect">
-            <a:avLst/>
-          </a:prstGeom>
-        </p:spPr>
-      </p:pic>
-      <p:sp>
-        <p:nvSpPr>
-          <p:cNvPr id="5" name="Rounded Rectangle 4"/>
-          <p:cNvSpPr/>
-          <p:nvPr/>
-        </p:nvSpPr>
-        <p:spPr>
-          <a:xfrm>
-            <a:off x="548640" y="548640"/>
-            <a:ext cx="8046720" cy="6400800"/>
-          </a:xfrm>
-          <a:prstGeom prst="roundRect">
-            <a:avLst>
-              <a:gd name="adj" fmla="val 8000"/>
-            </a:avLst>
-          </a:prstGeom>
-          <a:solidFill>
-            <a:srgbClr val="FFFFFF"/>
-          </a:solidFill>
-          <a:ln w="12700">
-            <a:solidFill>
-              <a:srgbClr val="DDD6FE"/>
-            </a:solidFill>
-          </a:ln>
-        </p:spPr>
-        <p:style>
-          <a:lnRef idx="1">
-            <a:schemeClr val="accent1"/>
-          </a:lnRef>
-          <a:fillRef idx="3">
-            <a:schemeClr val="accent1"/>
-          </a:fillRef>
-          <a:effectRef idx="2">
-            <a:schemeClr val="accent1"/>
-          </a:effectRef>
-          <a:fontRef idx="minor">
-            <a:schemeClr val="lt1"/>
-          </a:fontRef>
-        </p:style>
-        <p:txBody>
-          <a:bodyPr rtlCol="0" anchor="ctr"/>
-          <a:lstStyle/>
-          <a:p>
-            <a:pPr algn="ctr"/>
-          </a:p>
-        </p:txBody>
-      </p:sp>
-      <p:sp>
-        <p:nvSpPr>
-          <p:cNvPr id="6" name="Rectangle 5"/>
-          <p:cNvSpPr/>
-          <p:nvPr/>
-        </p:nvSpPr>
-        <p:spPr>
-          <a:xfrm>
-            <a:off x="548640" y="6858000"/>
-            <a:ext cx="8046720" cy="91440"/>
-          </a:xfrm>
-          <a:prstGeom prst="rect">
-            <a:avLst/>
-          </a:prstGeom>
-          <a:solidFill>
-            <a:srgbClr val="7C3AED"/>
-          </a:solidFill>
-          <a:ln>
-            <a:noFill/>
-          </a:ln>
-        </p:spPr>
-        <p:style>
-          <a:lnRef idx="1">
-            <a:schemeClr val="accent1"/>
-          </a:lnRef>
-          <a:fillRef idx="3">
-            <a:schemeClr val="accent1"/>
-          </a:fillRef>
-          <a:effectRef idx="2">
-            <a:schemeClr val="accent1"/>
-          </a:effectRef>
-          <a:fontRef idx="minor">
-            <a:schemeClr val="lt1"/>
-          </a:fontRef>
-        </p:style>
-        <p:txBody>
-          <a:bodyPr rtlCol="0" anchor="ctr"/>
-          <a:lstStyle/>
-          <a:p>
-            <a:pPr algn="ctr"/>
-          </a:p>
-        </p:txBody>
-      </p:sp>
-      <p:sp>
-        <p:nvSpPr>
-          <p:cNvPr id="7" name="TextBox 6"/>
-          <p:cNvSpPr txBox="1"/>
-          <p:nvPr/>
-        </p:nvSpPr>
-        <p:spPr>
-          <a:xfrm>
-            <a:off x="822960" y="749808"/>
-            <a:ext cx="7498080" cy="5998464"/>
-          </a:xfrm>
-          <a:prstGeom prst="rect">
-            <a:avLst/>
-          </a:prstGeom>
-          <a:noFill/>
-        </p:spPr>
-        <p:txBody>
-          <a:bodyPr wrap="square" lIns="0" rIns="0" tIns="0" bIns="0" anchor="t"/>
-          <a:lstStyle/>
-          <a:p>
-            <a:r>
-              <a:rPr b="1" sz="1500">
-                <a:solidFill>
-                  <a:srgbClr val="7C3AED"/>
-                </a:solidFill>
-              </a:rPr>
-              <a:t>DESPEDIDA</a:t>
-            </a:r>
-          </a:p>
-          <a:p>
-            <a:r>
-              <a:rPr b="1" sz="2600">
-                <a:solidFill>
-                  <a:srgbClr val="7C3AED"/>
-                </a:solidFill>
-              </a:rPr>
-              <a:t>QUIERO VIVIR AMANDO</a:t>
-            </a:r>
-          </a:p>
-          <a:p>
-            <a:pPr>
-              <a:spcBef>
-                <a:spcPts val="0"/>
-              </a:spcBef>
-              <a:spcAft>
-                <a:spcPts val="0"/>
-              </a:spcAft>
-            </a:pPr>
-          </a:p>
-          <a:p>
-            <a:pPr>
-              <a:lnSpc>
-                <a:spcPct val="105000"/>
-              </a:lnSpc>
-            </a:pPr>
-            <a:r>
-              <a:rPr b="0" sz="1900">
-                <a:solidFill>
-                  <a:srgbClr val="37352F"/>
-                </a:solidFill>
-              </a:rPr>
-              <a:t>No me resigno y busco siempre más, no me conformo con ser un mediocre.</a:t>
-            </a:r>
-          </a:p>
-          <a:p>
-            <a:pPr>
-              <a:lnSpc>
-                <a:spcPct val="105000"/>
-              </a:lnSpc>
-            </a:pPr>
-            <a:r>
-              <a:rPr b="0" sz="1900">
-                <a:solidFill>
-                  <a:srgbClr val="37352F"/>
-                </a:solidFill>
-              </a:rPr>
-              <a:t>Quiero tenerte cerca al caminar sólo contigo brillaré en la noche.</a:t>
-            </a:r>
-          </a:p>
-          <a:p>
-            <a:pPr>
-              <a:lnSpc>
-                <a:spcPct val="105000"/>
-              </a:lnSpc>
-            </a:pPr>
-            <a:r>
-              <a:rPr b="1" sz="1900">
-                <a:solidFill>
-                  <a:srgbClr val="37352F"/>
-                </a:solidFill>
-              </a:rPr>
-              <a:t>NO HAY AMOR, TODO ES MENTIRA</a:t>
-            </a:r>
-          </a:p>
-          <a:p>
-            <a:pPr>
-              <a:lnSpc>
-                <a:spcPct val="105000"/>
-              </a:lnSpc>
-            </a:pPr>
-            <a:r>
-              <a:rPr b="1" sz="1900">
-                <a:solidFill>
-                  <a:srgbClr val="37352F"/>
-                </a:solidFill>
-              </a:rPr>
-              <a:t>NO HAY AMOR,</a:t>
-            </a:r>
-          </a:p>
-          <a:p>
-            <a:pPr>
-              <a:lnSpc>
-                <a:spcPct val="105000"/>
-              </a:lnSpc>
-            </a:pPr>
-            <a:r>
-              <a:rPr b="1" sz="1900">
-                <a:solidFill>
-                  <a:srgbClr val="37352F"/>
-                </a:solidFill>
-              </a:rPr>
-              <a:t>TODO LO QUE VIVO PIERDE SU</a:t>
-            </a:r>
-          </a:p>
-          <a:p>
-            <a:pPr>
-              <a:lnSpc>
-                <a:spcPct val="105000"/>
-              </a:lnSpc>
-            </a:pPr>
-            <a:r>
-              <a:rPr b="0" sz="1900">
-                <a:solidFill>
-                  <a:srgbClr val="37352F"/>
-                </a:solidFill>
-              </a:rPr>
-              <a:t>COLOR Podría amontonar todo el saber, y ser el tío más listo de la tierra.</a:t>
-            </a:r>
-          </a:p>
-          <a:p>
-            <a:pPr>
-              <a:lnSpc>
-                <a:spcPct val="105000"/>
-              </a:lnSpc>
-            </a:pPr>
-            <a:r>
-              <a:rPr b="0" sz="1900">
-                <a:solidFill>
-                  <a:srgbClr val="37352F"/>
-                </a:solidFill>
-              </a:rPr>
-              <a:t>Podría dedicarme a resolver, todos los males y todas las guerras.</a:t>
-            </a:r>
-          </a:p>
-          <a:p>
-            <a:pPr>
-              <a:lnSpc>
-                <a:spcPct val="105000"/>
-              </a:lnSpc>
-            </a:pPr>
-            <a:r>
-              <a:rPr b="1" sz="1900">
-                <a:solidFill>
-                  <a:srgbClr val="37352F"/>
-                </a:solidFill>
-              </a:rPr>
-              <a:t>NO HAY AMOR, TODO ES MENTIRA</a:t>
-            </a:r>
-          </a:p>
-          <a:p>
-            <a:pPr>
-              <a:lnSpc>
-                <a:spcPct val="105000"/>
-              </a:lnSpc>
-            </a:pPr>
-            <a:r>
-              <a:rPr b="1" sz="1900">
-                <a:solidFill>
-                  <a:srgbClr val="37352F"/>
-                </a:solidFill>
-              </a:rPr>
-              <a:t>NO HAY AMOR,</a:t>
-            </a:r>
-          </a:p>
-          <a:p>
-            <a:pPr>
-              <a:lnSpc>
-                <a:spcPct val="105000"/>
-              </a:lnSpc>
-            </a:pPr>
-            <a:r>
-              <a:rPr b="1" sz="1900">
-                <a:solidFill>
-                  <a:srgbClr val="37352F"/>
-                </a:solidFill>
-              </a:rPr>
-              <a:t>TODO LO QUE VIVO PIERDE SU COLOR</a:t>
-            </a:r>
-          </a:p>
-          <a:p>
-            <a:pPr>
-              <a:lnSpc>
-                <a:spcPct val="105000"/>
-              </a:lnSpc>
-            </a:pPr>
-            <a:r>
-              <a:rPr b="1" sz="1900">
-                <a:solidFill>
-                  <a:srgbClr val="37352F"/>
-                </a:solidFill>
-              </a:rPr>
-              <a:t>QUIERO VIVIR AMANDO, QUIERO VIVIR</a:t>
-            </a:r>
-          </a:p>
-          <a:p>
-            <a:pPr>
-              <a:lnSpc>
-                <a:spcPct val="105000"/>
-              </a:lnSpc>
-            </a:pPr>
-            <a:r>
-              <a:rPr b="0" sz="1900">
-                <a:solidFill>
-                  <a:srgbClr val="37352F"/>
-                </a:solidFill>
-              </a:rPr>
-              <a:t>Re La Sol….</a:t>
-            </a:r>
-          </a:p>
-          <a:p>
-            <a:pPr>
-              <a:lnSpc>
-                <a:spcPct val="105000"/>
-              </a:lnSpc>
-            </a:pPr>
-            <a:r>
-              <a:rPr b="1" sz="1900">
-                <a:solidFill>
-                  <a:srgbClr val="37352F"/>
-                </a:solidFill>
-              </a:rPr>
-              <a:t>QUIERO VIVIR AMANDO, QUIERO VIVIR</a:t>
-            </a:r>
-          </a:p>
-          <a:p>
-            <a:pPr>
-              <a:lnSpc>
-                <a:spcPct val="105000"/>
-              </a:lnSpc>
-            </a:pPr>
-            <a:r>
-              <a:rPr b="0" sz="1900">
-                <a:solidFill>
-                  <a:srgbClr val="37352F"/>
-                </a:solidFill>
-              </a:rPr>
-              <a:t>Podría querer ser tu seguidor, dejarme quemar vivo a fuego lento y ganar cada mes más de un millón y repartirlo todo a los hambrientos.</a:t>
-            </a:r>
-          </a:p>
-          <a:p>
-            <a:pPr>
-              <a:lnSpc>
-                <a:spcPct val="105000"/>
-              </a:lnSpc>
-            </a:pPr>
-            <a:r>
-              <a:rPr b="1" sz="1900">
-                <a:solidFill>
-                  <a:srgbClr val="37352F"/>
-                </a:solidFill>
-              </a:rPr>
-              <a:t>NO HAY AMOR, TODO ES MENTIRA</a:t>
-            </a:r>
-          </a:p>
-          <a:p>
-            <a:pPr>
-              <a:lnSpc>
-                <a:spcPct val="105000"/>
-              </a:lnSpc>
-            </a:pPr>
-            <a:r>
-              <a:rPr b="1" sz="1900">
-                <a:solidFill>
-                  <a:srgbClr val="37352F"/>
-                </a:solidFill>
-              </a:rPr>
-              <a:t>NO HAY AMOR,</a:t>
-            </a:r>
-          </a:p>
-          <a:p>
-            <a:pPr>
-              <a:lnSpc>
-                <a:spcPct val="105000"/>
-              </a:lnSpc>
-            </a:pPr>
-            <a:r>
-              <a:rPr b="1" sz="1900">
-                <a:solidFill>
-                  <a:srgbClr val="37352F"/>
-                </a:solidFill>
-              </a:rPr>
-              <a:t>TODO LO QUE VIVO PIERDE SU</a:t>
-            </a:r>
-          </a:p>
-          <a:p>
-            <a:pPr>
-              <a:lnSpc>
-                <a:spcPct val="105000"/>
-              </a:lnSpc>
-            </a:pPr>
-            <a:r>
-              <a:rPr b="1" sz="1900">
-                <a:solidFill>
-                  <a:srgbClr val="37352F"/>
-                </a:solidFill>
-              </a:rPr>
-              <a:t>COLOR QUIERO VIVIR AMANDO, QUIERO VIVIR</a:t>
-            </a:r>
-          </a:p>
-          <a:p>
-            <a:pPr>
-              <a:lnSpc>
-                <a:spcPct val="105000"/>
-              </a:lnSpc>
-            </a:pPr>
-            <a:r>
-              <a:rPr b="1" sz="1900">
-                <a:solidFill>
-                  <a:srgbClr val="37352F"/>
-                </a:solidFill>
-              </a:rPr>
-              <a:t>QUIERO VIVIR AMANDO, QUIERO VIVIR O MORIR</a:t>
-            </a:r>
-          </a:p>
-          <a:p>
-            <a:pPr>
-              <a:lnSpc>
-                <a:spcPct val="105000"/>
-              </a:lnSpc>
-            </a:pPr>
-            <a:r>
-              <a:rPr b="0" sz="1900">
-                <a:solidFill>
-                  <a:srgbClr val="37352F"/>
-                </a:solidFill>
-              </a:rPr>
-              <a:t>El amor es servicio y no lleva cuentas del mal el amor no presume, no es egoísta.</a:t>
-            </a:r>
-          </a:p>
-          <a:p>
-            <a:pPr>
-              <a:lnSpc>
-                <a:spcPct val="105000"/>
-              </a:lnSpc>
-            </a:pPr>
-            <a:r>
-              <a:rPr b="0" sz="1900">
-                <a:solidFill>
-                  <a:srgbClr val="37352F"/>
-                </a:solidFill>
-              </a:rPr>
-              <a:t>El amor no se engríe, no se irrita ni te trata mal.</a:t>
-            </a:r>
-          </a:p>
-          <a:p>
-            <a:pPr>
-              <a:lnSpc>
-                <a:spcPct val="105000"/>
-              </a:lnSpc>
-            </a:pPr>
-            <a:r>
-              <a:rPr b="0" sz="1900">
-                <a:solidFill>
-                  <a:srgbClr val="37352F"/>
-                </a:solidFill>
-              </a:rPr>
-              <a:t>También es comprensivo, no tiene envidia.</a:t>
-            </a:r>
-          </a:p>
-          <a:p>
-            <a:pPr>
-              <a:lnSpc>
-                <a:spcPct val="105000"/>
-              </a:lnSpc>
-            </a:pPr>
-            <a:r>
-              <a:rPr b="0" sz="1900">
-                <a:solidFill>
-                  <a:srgbClr val="37352F"/>
-                </a:solidFill>
-              </a:rPr>
-              <a:t>Disculpa y cree sin límites.</a:t>
-            </a:r>
-          </a:p>
-          <a:p>
-            <a:pPr>
-              <a:lnSpc>
-                <a:spcPct val="105000"/>
-              </a:lnSpc>
-            </a:pPr>
-            <a:r>
-              <a:rPr b="0" sz="1900">
-                <a:solidFill>
-                  <a:srgbClr val="37352F"/>
-                </a:solidFill>
-              </a:rPr>
-              <a:t>Espera y aguanta sin límites.</a:t>
-            </a:r>
-          </a:p>
-          <a:p>
-            <a:pPr>
-              <a:lnSpc>
-                <a:spcPct val="105000"/>
-              </a:lnSpc>
-            </a:pPr>
-            <a:r>
-              <a:rPr b="0" sz="1900">
-                <a:solidFill>
-                  <a:srgbClr val="37352F"/>
-                </a:solidFill>
-              </a:rPr>
-              <a:t>El amor nunca pasará.</a:t>
-            </a:r>
-          </a:p>
-          <a:p>
-            <a:pPr>
-              <a:lnSpc>
-                <a:spcPct val="105000"/>
-              </a:lnSpc>
-            </a:pPr>
-            <a:r>
-              <a:rPr b="1" sz="1900">
-                <a:solidFill>
-                  <a:srgbClr val="37352F"/>
-                </a:solidFill>
-              </a:rPr>
-              <a:t>NO HAY AMOR, TODO ES MENTIRA</a:t>
-            </a:r>
-          </a:p>
-          <a:p>
-            <a:pPr>
-              <a:lnSpc>
-                <a:spcPct val="105000"/>
-              </a:lnSpc>
-            </a:pPr>
-            <a:r>
-              <a:rPr b="1" sz="1900">
-                <a:solidFill>
-                  <a:srgbClr val="37352F"/>
-                </a:solidFill>
-              </a:rPr>
-              <a:t>NO HAY AMOR,</a:t>
-            </a:r>
-          </a:p>
-          <a:p>
-            <a:pPr>
-              <a:lnSpc>
-                <a:spcPct val="105000"/>
-              </a:lnSpc>
-            </a:pPr>
-            <a:r>
-              <a:rPr b="1" sz="1900">
-                <a:solidFill>
-                  <a:srgbClr val="37352F"/>
-                </a:solidFill>
-              </a:rPr>
-              <a:t>TODO LO QUE VIVO PIERDE SU</a:t>
-            </a:r>
-          </a:p>
-          <a:p>
-            <a:pPr>
-              <a:lnSpc>
-                <a:spcPct val="105000"/>
-              </a:lnSpc>
-            </a:pPr>
-            <a:r>
-              <a:rPr b="1" sz="1900">
-                <a:solidFill>
-                  <a:srgbClr val="37352F"/>
-                </a:solidFill>
-              </a:rPr>
-              <a:t>COLOR QUIERO VIVIR AMANDO, QUIERO VIVIR</a:t>
-            </a:r>
-          </a:p>
-          <a:p>
-            <a:pPr>
-              <a:lnSpc>
-                <a:spcPct val="105000"/>
-              </a:lnSpc>
-            </a:pPr>
-            <a:r>
-              <a:rPr b="1" sz="1900">
-                <a:solidFill>
-                  <a:srgbClr val="37352F"/>
-                </a:solidFill>
-              </a:rPr>
-              <a:t>QUIERO VIVIR AMANDO, QUIERO VIVIR</a:t>
-            </a:r>
-          </a:p>
-          <a:p>
-            <a:pPr>
-              <a:lnSpc>
-                <a:spcPct val="105000"/>
-              </a:lnSpc>
-            </a:pPr>
-            <a:r>
-              <a:rPr b="0" sz="1900">
-                <a:solidFill>
-                  <a:srgbClr val="37352F"/>
-                </a:solidFill>
-              </a:rPr>
-              <a:t>Quiero vivir amando, porque el amor es Dios.</a:t>
-            </a:r>
-          </a:p>
-          <a:p>
-            <a:pPr>
-              <a:lnSpc>
-                <a:spcPct val="105000"/>
-              </a:lnSpc>
-            </a:pPr>
-            <a:r>
-              <a:rPr b="0" sz="1900">
-                <a:solidFill>
-                  <a:srgbClr val="37352F"/>
-                </a:solidFill>
-              </a:rPr>
-              <a:t>ReLaSim Sol Quiero vivir amando, porque el amor es Dios.</a:t>
-            </a:r>
-          </a:p>
-        </p:txBody>
-      </p:sp>
-    </p:spTree>
-  </p:cSld>
-  <p:clrMapOvr>
-    <a:masterClrMapping/>
-  </p:clrMapOvr>
-</p:sld>
-</file>
-
-<file path=ppt/slides/slide19.xml><?xml version="1.0" encoding="utf-8"?>
 <p:sld xmlns:a="http://schemas.openxmlformats.org/drawingml/2006/main" xmlns:p="http://schemas.openxmlformats.org/presentationml/2006/main" xmlns:r="http://schemas.openxmlformats.org/officeDocument/2006/relationships">
   <p:cSld>
     <p:bg>
@@ -7914,7 +6748,7 @@
                   <a:srgbClr val="7C3AED"/>
                 </a:solidFill>
               </a:rPr>
-              <a:t>PREPARAD EL CAMINO</a:t>
+              <a:t>HE VENIDO A SERVIR</a:t>
             </a:r>
           </a:p>
           <a:p>
@@ -7934,12 +6768,12 @@
               </a:lnSpc>
             </a:pPr>
             <a:r>
-              <a:rPr b="1" sz="1900">
-                <a:solidFill>
-                  <a:srgbClr val="37352F"/>
-                </a:solidFill>
-              </a:rPr>
-              <a:t>PREPARAD EL CAMINO</a:t>
+              <a:rPr b="0" sz="1900">
+                <a:solidFill>
+                  <a:srgbClr val="37352F"/>
+                </a:solidFill>
+              </a:rPr>
+              <a:t>Quien quiera ser grande, quien quiera ser el primero, sea el esclavo de todos, sea el más pequeño.</a:t>
             </a:r>
           </a:p>
           <a:p>
@@ -7949,12 +6783,12 @@
               </a:lnSpc>
             </a:pPr>
             <a:r>
-              <a:rPr b="1" sz="1900">
-                <a:solidFill>
-                  <a:srgbClr val="37352F"/>
-                </a:solidFill>
-              </a:rPr>
-              <a:t>PREPARAD EL CAMINO AL SEÑOR</a:t>
+              <a:rPr b="0" sz="1900">
+                <a:solidFill>
+                  <a:srgbClr val="37352F"/>
+                </a:solidFill>
+              </a:rPr>
+              <a:t>No he venido a ser servido, que he venido a servir y a dar la vida por todos para que todos puedan vivir (2)</a:t>
             </a:r>
           </a:p>
           <a:p>
@@ -7969,37 +6803,7 @@
                   <a:srgbClr val="37352F"/>
                 </a:solidFill>
               </a:rPr>
-              <a:t>Y ESCUCHAD LA PALABRA DE DIOS.(Bis)</a:t>
-            </a:r>
-          </a:p>
-          <a:p>
-            <a:pPr>
-              <a:lnSpc>
-                <a:spcPct val="105000"/>
-              </a:lnSpc>
-            </a:pPr>
-            <a:r>
-              <a:rPr b="0" sz="1900">
-                <a:solidFill>
-                  <a:srgbClr val="37352F"/>
-                </a:solidFill>
-              </a:rPr>
-              <a:t>Voz que clama en el desierto:</a:t>
-            </a:r>
-          </a:p>
-          <a:p>
-            <a:pPr>
-              <a:lnSpc>
-                <a:spcPct val="105000"/>
-              </a:lnSpc>
-            </a:pPr>
-            <a:r>
-              <a:rPr b="0" sz="1900">
-                <a:solidFill>
-                  <a:srgbClr val="37352F"/>
-                </a:solidFill>
-              </a:rPr>
-              <a:t>preparad los caminos de Dios, desterrad la mentira por siempre, preparad los caminos de Dios(Bis)</a:t>
+              <a:t>en plenitud (3).</a:t>
             </a:r>
           </a:p>
         </p:txBody>
@@ -8232,22 +7036,12 @@
           <a:lstStyle/>
           <a:p>
             <a:r>
-              <a:rPr b="1" sz="1500">
+              <a:rPr b="1" sz="2600">
                 <a:solidFill>
                   <a:srgbClr val="7C3AED"/>
                 </a:solidFill>
               </a:rPr>
               <a:t>ACTO PENITENCIAL</a:t>
-            </a:r>
-          </a:p>
-          <a:p>
-            <a:r>
-              <a:rPr b="1" sz="2600">
-                <a:solidFill>
-                  <a:srgbClr val="7C3AED"/>
-                </a:solidFill>
-              </a:rPr>
-              <a:t>OTRA OPORTUNIDAD</a:t>
             </a:r>
           </a:p>
           <a:p>
@@ -8272,7 +7066,7 @@
                   <a:srgbClr val="37352F"/>
                 </a:solidFill>
               </a:rPr>
-              <a:t>Me he perdido en mi caminar, tu camino quiero encontrar, porque sólo Tú eres Verdad.</a:t>
+              <a:t>Yo confieso ante Dios todopoderoso</a:t>
             </a:r>
           </a:p>
           <a:p>
@@ -8287,7 +7081,7 @@
                   <a:srgbClr val="37352F"/>
                 </a:solidFill>
               </a:rPr>
-              <a:t>Mas soy débil, fragilidad, y me olvido de tu verdad.</a:t>
+              <a:t>y ante vosotros, hermanos,</a:t>
             </a:r>
           </a:p>
           <a:p>
@@ -8302,7 +7096,7 @@
                   <a:srgbClr val="37352F"/>
                 </a:solidFill>
               </a:rPr>
-              <a:t>Debes perdonar.</a:t>
+              <a:t>que he pecado mucho de pensamiento, palabra, obra y omisión:</a:t>
             </a:r>
           </a:p>
           <a:p>
@@ -8317,7 +7111,62 @@
                   <a:srgbClr val="37352F"/>
                 </a:solidFill>
               </a:rPr>
-              <a:t>Dame otra oportunidad.</a:t>
+              <a:t>por mi culpa, por mi culpa, por mi gran culpa.</a:t>
+            </a:r>
+          </a:p>
+          <a:p>
+            <a:pPr>
+              <a:spcBef>
+                <a:spcPts val="0"/>
+              </a:spcBef>
+              <a:spcAft>
+                <a:spcPts val="0"/>
+              </a:spcAft>
+            </a:pPr>
+          </a:p>
+          <a:p>
+            <a:pPr>
+              <a:lnSpc>
+                <a:spcPct val="115000"/>
+              </a:lnSpc>
+            </a:pPr>
+            <a:r>
+              <a:rPr b="0" sz="2000">
+                <a:solidFill>
+                  <a:srgbClr val="37352F"/>
+                </a:solidFill>
+              </a:rPr>
+              <a:t>Por eso ruego a Santa María, siempre Virgen,</a:t>
+            </a:r>
+          </a:p>
+          <a:p>
+            <a:pPr>
+              <a:lnSpc>
+                <a:spcPct val="115000"/>
+              </a:lnSpc>
+            </a:pPr>
+            <a:r>
+              <a:rPr b="0" sz="2000">
+                <a:solidFill>
+                  <a:srgbClr val="37352F"/>
+                </a:solidFill>
+              </a:rPr>
+              <a:t>a los ángeles, a los santos y a vosotros, hermanos,</a:t>
+            </a:r>
+          </a:p>
+          <a:p>
+            <a:pPr>
+              <a:lnSpc>
+                <a:spcPct val="115000"/>
+              </a:lnSpc>
+            </a:pPr>
+            <a:r>
+              <a:rPr b="0" sz="2000">
+                <a:solidFill>
+                  <a:srgbClr val="37352F"/>
+                </a:solidFill>
+              </a:rPr>
+              <a:t>que intercedáis por mí ante Dios, nuestro Señor.</a:t>
             </a:r>
           </a:p>
         </p:txBody>
@@ -8565,7 +7414,7 @@
                   <a:srgbClr val="7C3AED"/>
                 </a:solidFill>
               </a:rPr>
-              <a:t>NO PREGUNTÉIS PORQUÉ</a:t>
+              <a:t>ALABO TU BONDAD</a:t>
             </a:r>
           </a:p>
           <a:p>
@@ -8590,7 +7439,7 @@
                   <a:srgbClr val="37352F"/>
                 </a:solidFill>
               </a:rPr>
-              <a:t>No preguntéis porqué, os lo pide el Señor.</a:t>
+              <a:t>Todo mi ser canta hoy por las cosas que hay en mí.</a:t>
             </a:r>
           </a:p>
           <a:p>
@@ -8605,7 +7454,7 @@
                   <a:srgbClr val="37352F"/>
                 </a:solidFill>
               </a:rPr>
-              <a:t>Vamos hacia Jerusalén, ésta es su razón.</a:t>
+              <a:t>Gracias te doy mi Señor,</a:t>
             </a:r>
           </a:p>
           <a:p>
@@ -8620,7 +7469,7 @@
                   <a:srgbClr val="37352F"/>
                 </a:solidFill>
               </a:rPr>
-              <a:t>Porque debéis saber que es tiempo de amor.</a:t>
+              <a:t>Tú me haces tan feliz.</a:t>
             </a:r>
           </a:p>
           <a:p>
@@ -8635,7 +7484,7 @@
                   <a:srgbClr val="37352F"/>
                 </a:solidFill>
               </a:rPr>
-              <a:t>Así nos lo ha dicho Él: ¡Alabad a Dios!</a:t>
+              <a:t>Tú me has regalado tu amistad, confío en ti, me llenas de tu paz.</a:t>
             </a:r>
           </a:p>
           <a:p>
@@ -8645,12 +7494,27 @@
               </a:lnSpc>
             </a:pPr>
             <a:r>
+              <a:rPr b="0" sz="1900">
+                <a:solidFill>
+                  <a:srgbClr val="37352F"/>
+                </a:solidFill>
+              </a:rPr>
+              <a:t>Tú me haces sentir tu gran bondad, yo cantaré por siempre tu fidelidad.</a:t>
+            </a:r>
+          </a:p>
+          <a:p>
+            <a:pPr>
+              <a:lnSpc>
+                <a:spcPct val="105000"/>
+              </a:lnSpc>
+            </a:pPr>
+            <a:r>
               <a:rPr b="1" sz="1900">
                 <a:solidFill>
                   <a:srgbClr val="37352F"/>
                 </a:solidFill>
               </a:rPr>
-              <a:t>HOSANNA, HOSANNA, GLORIA AL QUE VIENE</a:t>
+              <a:t>GLORIA A TI, SEÑOR POR TU BONDAD.</a:t>
             </a:r>
           </a:p>
           <a:p>
@@ -8665,7 +7529,7 @@
                   <a:srgbClr val="37352F"/>
                 </a:solidFill>
               </a:rPr>
-              <a:t>EN NOMBRE DEL SEÑOR (2).</a:t>
+              <a:t>GLORIA, GLORIA, SIEMPRE CANTARÉ TU FIDELIDAD.</a:t>
             </a:r>
           </a:p>
           <a:p>
@@ -8675,12 +7539,57 @@
               </a:lnSpc>
             </a:pPr>
             <a:r>
+              <a:rPr b="1" sz="1900">
+                <a:solidFill>
+                  <a:srgbClr val="37352F"/>
+                </a:solidFill>
+              </a:rPr>
+              <a:t>GLORIA A TI, SEÑOR POR TU BONDAD.</a:t>
+            </a:r>
+          </a:p>
+          <a:p>
+            <a:pPr>
+              <a:lnSpc>
+                <a:spcPct val="105000"/>
+              </a:lnSpc>
+            </a:pPr>
+            <a:r>
+              <a:rPr b="1" sz="1900">
+                <a:solidFill>
+                  <a:srgbClr val="37352F"/>
+                </a:solidFill>
+              </a:rPr>
+              <a:t>GLORIA, GLORIA, (TÚ ME HACES SENTIR TU GRAN BONDAD. YO CANTARÉ)</a:t>
+            </a:r>
+          </a:p>
+          <a:p>
+            <a:pPr>
+              <a:lnSpc>
+                <a:spcPct val="105000"/>
+              </a:lnSpc>
+            </a:pPr>
+            <a:r>
+              <a:rPr b="1" sz="1900">
+                <a:solidFill>
+                  <a:srgbClr val="37352F"/>
+                </a:solidFill>
+              </a:rPr>
+              <a:t>SIEMPRE CANTARÉ TU FIDELIDAD.</a:t>
+            </a:r>
+          </a:p>
+          <a:p>
+            <a:pPr>
+              <a:lnSpc>
+                <a:spcPct val="105000"/>
+              </a:lnSpc>
+            </a:pPr>
+            <a:r>
               <a:rPr b="0" sz="1900">
                 <a:solidFill>
                   <a:srgbClr val="37352F"/>
                 </a:solidFill>
               </a:rPr>
-              <a:t>Hoy me has hecho llorar, pobre Jerusalén.</a:t>
+              <a:t>(POR SIEMPRE TU FIDELIDAD)</a:t>
             </a:r>
           </a:p>
           <a:p>
@@ -8695,7 +7604,7 @@
                   <a:srgbClr val="37352F"/>
                 </a:solidFill>
               </a:rPr>
-              <a:t>No pierdas la oportunidad que te da tu Dios.</a:t>
+              <a:t>Siempre a tu lado estaré alabando tu bondad</a:t>
             </a:r>
           </a:p>
           <a:p>
@@ -8710,7 +7619,7 @@
                   <a:srgbClr val="37352F"/>
                 </a:solidFill>
               </a:rPr>
-              <a:t>Ya no temas Sión, mira tu rey está aquí,</a:t>
+              <a:t>A mis hermanos diré el gran gozo que hallo en ti.</a:t>
             </a:r>
           </a:p>
           <a:p>
@@ -8725,7 +7634,7 @@
                   <a:srgbClr val="37352F"/>
                 </a:solidFill>
               </a:rPr>
-              <a:t>Y su llanto convertirá en sonrisa y perdón.</a:t>
+              <a:t>En ti podrán siempre encontrar fidelidad, confianza y amistad.</a:t>
             </a:r>
           </a:p>
           <a:p>
@@ -8740,22 +7649,7 @@
                   <a:srgbClr val="37352F"/>
                 </a:solidFill>
               </a:rPr>
-              <a:t>Cómo hacemos callar, si es un canto de amor,</a:t>
-            </a:r>
-          </a:p>
-          <a:p>
-            <a:pPr>
-              <a:lnSpc>
-                <a:spcPct val="105000"/>
-              </a:lnSpc>
-            </a:pPr>
-            <a:r>
-              <a:rPr b="0" sz="1900">
-                <a:solidFill>
-                  <a:srgbClr val="37352F"/>
-                </a:solidFill>
-              </a:rPr>
-              <a:t>Y hasta las piedras gritarán: ¡Alabad a Dios!</a:t>
+              <a:t>Nunca fallará tu gran amor, ni tu perdón. Me quieres tal como soy</a:t>
             </a:r>
           </a:p>
         </p:txBody>
@@ -9276,7 +8170,7 @@
                   <a:srgbClr val="7C3AED"/>
                 </a:solidFill>
               </a:rPr>
-              <a:t>SALMO RESPONSORIAL (1/2)</a:t>
+              <a:t>SALMO RESPONSORIAL</a:t>
             </a:r>
           </a:p>
           <a:p>
@@ -9321,7 +8215,7 @@
                   <a:srgbClr val="37352F"/>
                 </a:solidFill>
               </a:rPr>
-              <a:t>Antífona: Recuerda, Señor, que tu misericordia es eterna; Señor, enséñame tus caminos, instrúyeme en tus sendas: haz que camine con lealtad; enséñame, porque tú eres mi Dios y Salvador, y todo el día te estoy esperando.</a:t>
+              <a:t>Antífona: Recuerda, Señor, que tu misericordia es eterna</a:t>
             </a:r>
           </a:p>
           <a:p>
@@ -9346,7 +8240,7 @@
                   <a:srgbClr val="37352F"/>
                 </a:solidFill>
               </a:rPr>
-              <a:t>Recuerda, Señor, que tu ternura y tu misericordia son eternas; no te acuerdes de los pecados; ni de las maldades de mi juventud; acuérdate de mí con misericordia, por tu bondad, Señor.</a:t>
+              <a:t>Señor, enséñame tus caminos, instrúyeme en tus sendas: haz que camine con lealtad; enséñame, porque tú eres mi Dios y Salvador, y todo el día te estoy esperando.</a:t>
             </a:r>
           </a:p>
           <a:p>
@@ -9371,39 +8265,7 @@
                   <a:srgbClr val="37352F"/>
                 </a:solidFill>
               </a:rPr>
-              <a:t>El Señor es bueno y es recto, y enseña el camino a los pecadores; hace caminar a los humildes con rectitud, enseña su camino a los humildes.; --YA DE MAÑANA; Fam# Dom# Re Mi; Dom# YA DE MAÑANA OYES MI VOZ CUANDO ME PONGO ANTE TI, Fam# Re ESPERÁNDOTE SEÑOR; </a:t>
-            </a:r>
-            <a:r>
-              <a:rPr b="1" sz="2000">
-                <a:solidFill>
-                  <a:srgbClr val="37352F"/>
-                </a:solidFill>
-              </a:rPr>
-              <a:t>PORQUE YA DE MAÑANA OYES MI VOZ,</a:t>
-            </a:r>
-            <a:r>
-              <a:rPr b="0" sz="2000">
-                <a:solidFill>
-                  <a:srgbClr val="37352F"/>
-                </a:solidFill>
-              </a:rPr>
-              <a:t>; </a:t>
-            </a:r>
-            <a:r>
-              <a:rPr b="1" sz="2000">
-                <a:solidFill>
-                  <a:srgbClr val="37352F"/>
-                </a:solidFill>
-              </a:rPr>
-              <a:t>PORQUE YA DE MAÑANA OYES MI VOZ.</a:t>
-            </a:r>
-            <a:r>
-              <a:rPr b="0" sz="2000">
-                <a:solidFill>
-                  <a:srgbClr val="37352F"/>
-                </a:solidFill>
-              </a:rPr>
-              <a:t>; Dom# Fam# Dom#; Escucha mis palabras, oye mis lamentos, cuando presento mi súplica ante ti,¡ Oh mi rey y mi Dios !, La Dom# Fam#; Dom# Guíame oh Yahveh en tu justicia, allana también tu camino ante mí, ¡Oh mi rey y mi Dios !</a:t>
+              <a:t>Recuerda, Señor, que tu ternura y tu misericordia son eternas; no te acuerdes de los pecados; ni de las maldades de mi juventud; acuérdate de mí con misericordia, por tu bondad, Señor.</a:t>
             </a:r>
           </a:p>
           <a:p>
@@ -9428,7 +8290,7 @@
                   <a:srgbClr val="37352F"/>
                 </a:solidFill>
               </a:rPr>
-              <a:t>Los que aman tu nombre, los que a ti se acogen, se alegren, exulten por siempre y alborocen ¡ Oh mi rey y mi Dios !</a:t>
+              <a:t>El Señor es bueno y es recto, y enseña el camino a los pecadores; hace caminar a los humildes con rectitud, enseña su camino a los humildes.</a:t>
             </a:r>
           </a:p>
         </p:txBody>
@@ -9528,7 +8390,7 @@
       </p:pic>
       <p:pic>
         <p:nvPicPr>
-          <p:cNvPr id="4" name="Picture 3" descr="fano_20140360_recibimos_para_hacer_crecer.jpg"/>
+          <p:cNvPr id="4" name="Picture 3" descr="fano_20140941_aprende_a_elegir_el_pan_de_la_palabra.jpg"/>
           <p:cNvPicPr>
             <a:picLocks noChangeAspect="1"/>
           </p:cNvPicPr>
@@ -9543,7 +8405,7 @@
         <p:spPr>
           <a:xfrm>
             <a:off x="6675120" y="1005840"/>
-            <a:ext cx="4281472" cy="2560320"/>
+            <a:ext cx="3830072" cy="2560320"/>
           </a:xfrm>
           <a:prstGeom prst="rect">
             <a:avLst/>
@@ -9666,7 +8528,7 @@
                   <a:srgbClr val="7C3AED"/>
                 </a:solidFill>
               </a:rPr>
-              <a:t>SALMO RESPONSORIAL (2/2)</a:t>
+              <a:t>SEGUNDA LECTURA</a:t>
             </a:r>
           </a:p>
           <a:p>
@@ -9686,7 +8548,7 @@
                   <a:srgbClr val="D4A76A"/>
                 </a:solidFill>
               </a:rPr>
-              <a:t>Salmo Sal 24,4</a:t>
+              <a:t>Filipenses 2,1-11</a:t>
             </a:r>
           </a:p>
           <a:p>
@@ -9711,7 +8573,7 @@
                   <a:srgbClr val="37352F"/>
                 </a:solidFill>
               </a:rPr>
-              <a:t>Escucha mis palabras oye mis lamentos, cuando presento mi súplica ante ti, ¡ Oh mi rey y mi Dios !; ...Tú en la noche, tarde... oyes mi voz...</a:t>
+              <a:t>Si queréis darme el consuelo de Cristo y aliviarme con vuestro amor, si nos une el mismo Espíritu y tenéis entrañas compasivas, dadme esta gran alegría: manteneos unánimes y concordes con un mismo amor y un mismo sentir. No obréis por rivalidad ni por ostentación, dejaos guiar por la humildad y considerad siempre superiores a los demás. No os encerréis en vuestros intereses, sino buscad todos el interés de los demás. Tened entre vosotros los sentimientos propios de Cristo Jesús. Él, a pesar de su condición divina, no hizo alarde de su categoría de Dios; al contrario, se despojó de su rango y tomó la condición de esclavo, pasando por uno de tantos. Y así, actuando como un hombre cualquiera, se rebajó hasta someterse incluso a la muerte, y una muerte de cruz. Por eso Dios lo levantó sobre todo y le concedió el Nombre-sobre-todo-nombre; de modo que al nombre de Jesús toda rodilla se doble en el cielo, en la tierra, en el abismo, y toda lengua proclame: Jesucristo es Señor, para gloria de Dios Padre.</a:t>
             </a:r>
           </a:p>
         </p:txBody>
@@ -9811,7 +8673,7 @@
       </p:pic>
       <p:pic>
         <p:nvPicPr>
-          <p:cNvPr id="4" name="Picture 3" descr="fano_20140941_aprende_a_elegir_el_pan_de_la_palabra.jpg"/>
+          <p:cNvPr id="4" name="Picture 3" descr="fano_20140573_viviré_para_alabar_hacer_reverencia_y_servir_a_jesús_mi_rey.jpg"/>
           <p:cNvPicPr>
             <a:picLocks noChangeAspect="1"/>
           </p:cNvPicPr>
@@ -9826,7 +8688,7 @@
         <p:spPr>
           <a:xfrm>
             <a:off x="6675120" y="1005840"/>
-            <a:ext cx="3830072" cy="2560320"/>
+            <a:ext cx="2880360" cy="2560320"/>
           </a:xfrm>
           <a:prstGeom prst="rect">
             <a:avLst/>
@@ -9944,12 +8806,22 @@
           <a:lstStyle/>
           <a:p>
             <a:r>
+              <a:rPr b="1" sz="1500">
+                <a:solidFill>
+                  <a:srgbClr val="7C3AED"/>
+                </a:solidFill>
+              </a:rPr>
+              <a:t>ALELUYA</a:t>
+            </a:r>
+          </a:p>
+          <a:p>
+            <a:r>
               <a:rPr b="1" sz="2600">
                 <a:solidFill>
                   <a:srgbClr val="7C3AED"/>
                 </a:solidFill>
               </a:rPr>
-              <a:t>SEGUNDA LECTURA</a:t>
+              <a:t>ALELUYA DE LA TIERRA</a:t>
             </a:r>
           </a:p>
           <a:p>
@@ -9963,38 +8835,168 @@
             </a:pPr>
           </a:p>
           <a:p>
-            <a:r>
-              <a:rPr b="1" sz="1500">
-                <a:solidFill>
-                  <a:srgbClr val="D4A76A"/>
-                </a:solidFill>
-              </a:rPr>
-              <a:t>Filipenses 2,1-11</a:t>
-            </a:r>
-          </a:p>
-          <a:p>
-            <a:pPr>
-              <a:spcBef>
-                <a:spcPts val="0"/>
-              </a:spcBef>
-              <a:spcAft>
-                <a:spcPts val="0"/>
-              </a:spcAft>
-            </a:pPr>
-          </a:p>
-          <a:p>
-            <a:pPr>
-              <a:lnSpc>
-                <a:spcPct val="115000"/>
-              </a:lnSpc>
-            </a:pPr>
-            <a:r>
-              <a:rPr b="0" sz="2000">
-                <a:solidFill>
-                  <a:srgbClr val="37352F"/>
-                </a:solidFill>
-              </a:rPr>
-              <a:t>Si queréis darme el consuelo de Cristo y aliviarme con vuestro amor, si nos une el mismo Espíritu y tenéis entrañas compasivas, dadme esta gran alegría: manteneos unánimes y concordes con un mismo amor y un mismo sentir. No obréis por rivalidad ni por ostentación, dejaos guiar por la humildad y considerad siempre superiores a los demás. No os encerréis en vuestros intereses, sino buscad todos el interés de los demás. Tened entre vosotros los sentimientos propios de Cristo Jesús. Él, a pesar de su condición divina, no hizo alarde de su categoría de Dios; al contrario, se despojó de su rango y tomó la condición de esclavo, pasando por uno de tantos. Y así, actuando como un hombre cualquiera, se rebajó hasta someterse incluso a la muerte, y una muerte de cruz. Por eso Dios lo levantó sobre todo y le concedió el Nombre-sobre-todo-nombre; de modo que al nombre de Jesús toda rodilla se doble en el cielo, en la tierra, en el abismo, y toda lengua proclame: Jesucristo es Señor, para gloria de Dios Padre.</a:t>
+            <a:pPr>
+              <a:lnSpc>
+                <a:spcPct val="105000"/>
+              </a:lnSpc>
+            </a:pPr>
+            <a:r>
+              <a:rPr b="0" sz="1900">
+                <a:solidFill>
+                  <a:srgbClr val="37352F"/>
+                </a:solidFill>
+              </a:rPr>
+              <a:t>¿Quién quiere resucitar a este mundo que se muere?</a:t>
+            </a:r>
+          </a:p>
+          <a:p>
+            <a:pPr>
+              <a:lnSpc>
+                <a:spcPct val="105000"/>
+              </a:lnSpc>
+            </a:pPr>
+            <a:r>
+              <a:rPr b="0" sz="1900">
+                <a:solidFill>
+                  <a:srgbClr val="37352F"/>
+                </a:solidFill>
+              </a:rPr>
+              <a:t>¿Quién cantará el aleluya de esa nueva luz que viene?</a:t>
+            </a:r>
+          </a:p>
+          <a:p>
+            <a:pPr>
+              <a:lnSpc>
+                <a:spcPct val="105000"/>
+              </a:lnSpc>
+            </a:pPr>
+            <a:r>
+              <a:rPr b="0" sz="1900">
+                <a:solidFill>
+                  <a:srgbClr val="37352F"/>
+                </a:solidFill>
+              </a:rPr>
+              <a:t>¿Quién cuando mire la tierra y las tragedias observe, sentirá en su corazón el dolor de quien se muere?</a:t>
+            </a:r>
+          </a:p>
+          <a:p>
+            <a:pPr>
+              <a:lnSpc>
+                <a:spcPct val="105000"/>
+              </a:lnSpc>
+            </a:pPr>
+            <a:r>
+              <a:rPr b="0" sz="1900">
+                <a:solidFill>
+                  <a:srgbClr val="37352F"/>
+                </a:solidFill>
+              </a:rPr>
+              <a:t>¿Quién es capaz de salvar a este mundo decadente, y mantiene la esperanza de los muchos que la pierden?</a:t>
+            </a:r>
+          </a:p>
+          <a:p>
+            <a:pPr>
+              <a:lnSpc>
+                <a:spcPct val="105000"/>
+              </a:lnSpc>
+            </a:pPr>
+            <a:r>
+              <a:rPr b="1" sz="1900">
+                <a:solidFill>
+                  <a:srgbClr val="37352F"/>
+                </a:solidFill>
+              </a:rPr>
+              <a:t>EL QUE SUFRE, MATA Y MUERE, DESESPERA Y ENLOQUECE,</a:t>
+            </a:r>
+          </a:p>
+          <a:p>
+            <a:pPr>
+              <a:lnSpc>
+                <a:spcPct val="105000"/>
+              </a:lnSpc>
+            </a:pPr>
+            <a:r>
+              <a:rPr b="1" sz="1900">
+                <a:solidFill>
+                  <a:srgbClr val="37352F"/>
+                </a:solidFill>
+              </a:rPr>
+              <a:t>Y OTROS SON ESPECTADORES, NO LO SIENTEN.</a:t>
+            </a:r>
+          </a:p>
+          <a:p>
+            <a:pPr>
+              <a:lnSpc>
+                <a:spcPct val="105000"/>
+              </a:lnSpc>
+            </a:pPr>
+            <a:r>
+              <a:rPr b="0" sz="1900">
+                <a:solidFill>
+                  <a:srgbClr val="37352F"/>
+                </a:solidFill>
+              </a:rPr>
+              <a:t>¿Quién bajará de la cruz a tanto cristo sufriente, mientras los hombres miramos, impasivos e indolentes?</a:t>
+            </a:r>
+          </a:p>
+          <a:p>
+            <a:pPr>
+              <a:lnSpc>
+                <a:spcPct val="105000"/>
+              </a:lnSpc>
+            </a:pPr>
+            <a:r>
+              <a:rPr b="0" sz="1900">
+                <a:solidFill>
+                  <a:srgbClr val="37352F"/>
+                </a:solidFill>
+              </a:rPr>
+              <a:t>¿Quién grita desde el silencio de un ser que a su Dios retiene, porque se hace palabra que sin hablar se la entiende?</a:t>
+            </a:r>
+          </a:p>
+          <a:p>
+            <a:pPr>
+              <a:lnSpc>
+                <a:spcPct val="105000"/>
+              </a:lnSpc>
+            </a:pPr>
+            <a:r>
+              <a:rPr b="0" sz="1900">
+                <a:solidFill>
+                  <a:srgbClr val="37352F"/>
+                </a:solidFill>
+              </a:rPr>
+              <a:t>¿Quién se torna en aleluya porque traduce la muerte, como el trigo que se pudre y de uno cientos vienen?</a:t>
+            </a:r>
+          </a:p>
+          <a:p>
+            <a:pPr>
+              <a:lnSpc>
+                <a:spcPct val="105000"/>
+              </a:lnSpc>
+            </a:pPr>
+            <a:r>
+              <a:rPr b="1" sz="1900">
+                <a:solidFill>
+                  <a:srgbClr val="37352F"/>
+                </a:solidFill>
+              </a:rPr>
+              <a:t>¡ALELUYA! CANTARÁ, QUIEN PERDIÓ LA ESPERANZA,</a:t>
+            </a:r>
+          </a:p>
+          <a:p>
+            <a:pPr>
+              <a:lnSpc>
+                <a:spcPct val="105000"/>
+              </a:lnSpc>
+            </a:pPr>
+            <a:r>
+              <a:rPr b="1" sz="1900">
+                <a:solidFill>
+                  <a:srgbClr val="37352F"/>
+                </a:solidFill>
+              </a:rPr>
+              <a:t>Y LA TIERRA SONREIRÁ. ¡ALELUYA!</a:t>
             </a:r>
           </a:p>
         </p:txBody>
@@ -10094,7 +9096,7 @@
       </p:pic>
       <p:pic>
         <p:nvPicPr>
-          <p:cNvPr id="4" name="Picture 3" descr="fano_20140573_viviré_para_alabar_hacer_reverencia_y_servir_a_jesús_mi_rey.jpg"/>
+          <p:cNvPr id="4" name="Picture 3" descr="fano_20140639_sin_titulo.jpg"/>
           <p:cNvPicPr>
             <a:picLocks noChangeAspect="1"/>
           </p:cNvPicPr>
@@ -10109,7 +9111,7 @@
         <p:spPr>
           <a:xfrm>
             <a:off x="6675120" y="1005840"/>
-            <a:ext cx="2880360" cy="2560320"/>
+            <a:ext cx="4000500" cy="2560320"/>
           </a:xfrm>
           <a:prstGeom prst="rect">
             <a:avLst/>
@@ -10227,22 +9229,12 @@
           <a:lstStyle/>
           <a:p>
             <a:r>
-              <a:rPr b="1" sz="1500">
+              <a:rPr b="1" sz="2600">
                 <a:solidFill>
                   <a:srgbClr val="7C3AED"/>
                 </a:solidFill>
               </a:rPr>
-              <a:t>ALELUYA</a:t>
-            </a:r>
-          </a:p>
-          <a:p>
-            <a:r>
-              <a:rPr b="1" sz="2600">
-                <a:solidFill>
-                  <a:srgbClr val="7C3AED"/>
-                </a:solidFill>
-              </a:rPr>
-              <a:t>ESCUCHA, TÚ</a:t>
+              <a:t>EVANGELIO</a:t>
             </a:r>
           </a:p>
           <a:p>
@@ -10256,78 +9248,53 @@
             </a:pPr>
           </a:p>
           <a:p>
-            <a:pPr>
-              <a:lnSpc>
-                <a:spcPct val="105000"/>
-              </a:lnSpc>
-            </a:pPr>
-            <a:r>
-              <a:rPr b="0" sz="1900">
-                <a:solidFill>
-                  <a:srgbClr val="37352F"/>
-                </a:solidFill>
-              </a:rPr>
-              <a:t>Escucha tú la palabra de Dios, no sólo con tus oídos, también con el corazón.</a:t>
-            </a:r>
-          </a:p>
-          <a:p>
-            <a:pPr>
-              <a:lnSpc>
-                <a:spcPct val="105000"/>
-              </a:lnSpc>
-            </a:pPr>
-            <a:r>
-              <a:rPr b="0" sz="1900">
-                <a:solidFill>
-                  <a:srgbClr val="37352F"/>
-                </a:solidFill>
-              </a:rPr>
-              <a:t>Escucha tú la palabra de Dios, y estate siempre atento a su voz.</a:t>
-            </a:r>
-          </a:p>
-          <a:p>
-            <a:pPr>
-              <a:lnSpc>
-                <a:spcPct val="105000"/>
-              </a:lnSpc>
-            </a:pPr>
-            <a:r>
-              <a:rPr b="0" sz="1900">
-                <a:solidFill>
-                  <a:srgbClr val="37352F"/>
-                </a:solidFill>
-              </a:rPr>
-              <a:t>Déjala entrar dentro de tu corazón, pásala a tu mente y a tu situación.</a:t>
-            </a:r>
-          </a:p>
-          <a:p>
-            <a:pPr>
-              <a:lnSpc>
-                <a:spcPct val="105000"/>
-              </a:lnSpc>
-            </a:pPr>
-            <a:r>
-              <a:rPr b="0" sz="1900">
-                <a:solidFill>
-                  <a:srgbClr val="37352F"/>
-                </a:solidFill>
-              </a:rPr>
-              <a:t>Vívela, vívela, en tu realidad.</a:t>
-            </a:r>
-          </a:p>
-          <a:p>
-            <a:pPr>
-              <a:lnSpc>
-                <a:spcPct val="105000"/>
-              </a:lnSpc>
-            </a:pPr>
-            <a:r>
-              <a:rPr b="0" sz="1900">
-                <a:solidFill>
-                  <a:srgbClr val="37352F"/>
-                </a:solidFill>
-              </a:rPr>
-              <a:t>Haz que por tu vida llegue a los demás.</a:t>
+            <a:r>
+              <a:rPr b="1" sz="1500">
+                <a:solidFill>
+                  <a:srgbClr val="D4A76A"/>
+                </a:solidFill>
+              </a:rPr>
+              <a:t>Mateo 21,28-32</a:t>
+            </a:r>
+          </a:p>
+          <a:p>
+            <a:pPr>
+              <a:spcBef>
+                <a:spcPts val="0"/>
+              </a:spcBef>
+              <a:spcAft>
+                <a:spcPts val="0"/>
+              </a:spcAft>
+            </a:pPr>
+          </a:p>
+          <a:p>
+            <a:pPr>
+              <a:lnSpc>
+                <a:spcPct val="115000"/>
+              </a:lnSpc>
+            </a:pPr>
+            <a:r>
+              <a:rPr b="0" sz="2000">
+                <a:solidFill>
+                  <a:srgbClr val="37352F"/>
+                </a:solidFill>
+              </a:rPr>
+              <a:t>En aquel tiempo, dijo Jesús a los sumos sacerdotes y a los ancianos del pueblo: «¿Qué os parece? Un hombre tenía dos hijos. Se acercó al primero y le dijo: «Hijo, ve hoy a trabajar en la viña.» Él le contestó: «No quiero.» Pero después recapacitó y fue. Se acercó al segundo y le dijo lo mismo. Él le contestó: «Voy, señor.» Pero no fue. ¿Quién de los dos hizo lo que quería el padre?»Contestaron: «El primero.»Jesús les dijo: «Os aseguro que los publicanos y las prostitutas os llevan la delantera en el camino del reino de Dios. Porque vino Juan a vosotros enseñándoos el camino de la justicia, y no le creísteis; en cambio, los publicanos y prostitutas le creyeron. Y, aun después de ver esto, vosotros no recapacitasteis ni le creísteis.»</a:t>
+            </a:r>
+          </a:p>
+          <a:p>
+            <a:pPr>
+              <a:lnSpc>
+                <a:spcPct val="115000"/>
+              </a:lnSpc>
+            </a:pPr>
+            <a:r>
+              <a:rPr b="0" sz="2000">
+                <a:solidFill>
+                  <a:srgbClr val="37352F"/>
+                </a:solidFill>
+              </a:rPr>
+              <a:t>Palabra del Señor</a:t>
             </a:r>
           </a:p>
         </p:txBody>

</xml_diff>